<commit_message>
Document the lab leave-behind and ignore Office lockfiles.
Co-authored-by: Cursor <cursoragent@cursor.com>
</commit_message>
<xml_diff>
--- a/Image_governance_spec.pptx
+++ b/Image_governance_spec.pptx
@@ -4,6 +4,9 @@
   <p:sldMasterIdLst>
     <p:sldMasterId id="2147483648" r:id="rId1"/>
   </p:sldMasterIdLst>
+  <p:notesMasterIdLst>
+    <p:notesMasterId r:id="rId12"/>
+  </p:notesMasterIdLst>
   <p:sldIdLst>
     <p:sldId id="256" r:id="rId2"/>
     <p:sldId id="257" r:id="rId3"/>
@@ -16,9 +19,6 @@
     <p:sldId id="264" r:id="rId10"/>
     <p:sldId id="265" r:id="rId11"/>
   </p:sldIdLst>
-  <p:notesMasterIdLst>
-    <p:notesMasterId r:id="rId12"/>
-  </p:notesMasterIdLst>
   <p:sldSz cx="18288000" cy="10287000"/>
   <p:notesSz cx="10287000" cy="18288000"/>
   <p:defaultTextStyle>
@@ -113,6 +113,11 @@
       </a:defRPr>
     </a:lvl9pPr>
   </p:defaultTextStyle>
+  <p:extLst>
+    <p:ext uri="{EFAFB233-063F-42B5-8137-9DF3F51BA10A}">
+      <p15:sldGuideLst xmlns:p15="http://schemas.microsoft.com/office/powerpoint/2012/main"/>
+    </p:ext>
+  </p:extLst>
 </p:presentation>
 </file>
 
@@ -138,234 +143,10 @@
           <a:chExt cx="0" cy="0"/>
         </a:xfrm>
       </p:grpSpPr>
-      <p:sp>
-        <p:nvSpPr>
-          <p:cNvPr id="2" name="Header Placeholder 1"/>
-          <p:cNvSpPr>
-            <a:spLocks noGrp="1"/>
-          </p:cNvSpPr>
-          <p:nvPr>
-            <p:ph type="hdr" sz="quarter"/>
-          </p:nvPr>
-        </p:nvSpPr>
-        <p:spPr>
-          <a:xfrm>
-            <a:off x="0" y="0"/>
-            <a:ext cx="2971800" cy="458788"/>
-          </a:xfrm>
-          <a:prstGeom prst="rect">
-            <a:avLst/>
-          </a:prstGeom>
-        </p:spPr>
-        <p:txBody>
-          <a:bodyPr vert="horz" lIns="91440" tIns="45720" rIns="91440" bIns="45720" rtlCol="0"/>
-          <a:lstStyle>
-            <a:lvl1pPr algn="l">
-              <a:defRPr sz="1200"/>
-            </a:lvl1pPr>
-          </a:lstStyle>
-          <a:p>
-            <a:endParaRPr lang="en-US"/>
-          </a:p>
-        </p:txBody>
-      </p:sp>
-      <p:sp>
-        <p:nvSpPr>
-          <p:cNvPr id="3" name="Date Placeholder 2"/>
-          <p:cNvSpPr>
-            <a:spLocks noGrp="1"/>
-          </p:cNvSpPr>
-          <p:nvPr>
-            <p:ph type="dt" idx="1"/>
-          </p:nvPr>
-        </p:nvSpPr>
-        <p:spPr>
-          <a:xfrm>
-            <a:off x="3884613" y="0"/>
-            <a:ext cx="2971800" cy="458788"/>
-          </a:xfrm>
-          <a:prstGeom prst="rect">
-            <a:avLst/>
-          </a:prstGeom>
-        </p:spPr>
-        <p:txBody>
-          <a:bodyPr vert="horz" lIns="91440" tIns="45720" rIns="91440" bIns="45720" rtlCol="0"/>
-          <a:lstStyle>
-            <a:lvl1pPr algn="r">
-              <a:defRPr sz="1200"/>
-            </a:lvl1pPr>
-          </a:lstStyle>
-          <a:p>
-            <a:fld id="{5282F153-3F37-0F45-9E97-73ACFA13230C}" type="datetimeFigureOut">
-              <a:rPr lang="en-US"/>
-              <a:t>7/23/19</a:t>
-            </a:fld>
-            <a:endParaRPr lang="en-US"/>
-          </a:p>
-        </p:txBody>
-      </p:sp>
-      <p:sp>
-        <p:nvSpPr>
-          <p:cNvPr id="4" name="Slide Image Placeholder 3"/>
-          <p:cNvSpPr>
-            <a:spLocks noGrp="1" noRot="1" noChangeAspect="1"/>
-          </p:cNvSpPr>
-          <p:nvPr>
-            <p:ph type="sldImg" idx="2"/>
-          </p:nvPr>
-        </p:nvSpPr>
-        <p:spPr>
-          <a:xfrm>
-            <a:off x="685800" y="1143000"/>
-            <a:ext cx="5486400" cy="3086100"/>
-          </a:xfrm>
-          <a:prstGeom prst="rect">
-            <a:avLst/>
-          </a:prstGeom>
-          <a:noFill/>
-          <a:ln w="12700">
-            <a:solidFill>
-              <a:prstClr val="black"/>
-            </a:solidFill>
-          </a:ln>
-        </p:spPr>
-        <p:txBody>
-          <a:bodyPr vert="horz" lIns="91440" tIns="45720" rIns="91440" bIns="45720" rtlCol="0" anchor="ctr"/>
-          <a:lstStyle/>
-          <a:p>
-            <a:endParaRPr lang="en-US"/>
-          </a:p>
-        </p:txBody>
-      </p:sp>
-      <p:sp>
-        <p:nvSpPr>
-          <p:cNvPr id="5" name="Notes Placeholder 4"/>
-          <p:cNvSpPr>
-            <a:spLocks noGrp="1"/>
-          </p:cNvSpPr>
-          <p:nvPr>
-            <p:ph type="body" sz="quarter" idx="3"/>
-          </p:nvPr>
-        </p:nvSpPr>
-        <p:spPr>
-          <a:xfrm>
-            <a:off x="685800" y="4400550"/>
-            <a:ext cx="5486400" cy="3600450"/>
-          </a:xfrm>
-          <a:prstGeom prst="rect">
-            <a:avLst/>
-          </a:prstGeom>
-        </p:spPr>
-        <p:txBody>
-          <a:bodyPr vert="horz" lIns="91440" tIns="45720" rIns="91440" bIns="45720" rtlCol="0"/>
-          <a:lstStyle/>
-          <a:p>
-            <a:pPr lvl="0"/>
-            <a:r>
-              <a:rPr lang="en-US"/>
-              <a:t>Click to edit Master text styles</a:t>
-            </a:r>
-          </a:p>
-          <a:p>
-            <a:pPr lvl="1"/>
-            <a:r>
-              <a:rPr lang="en-US"/>
-              <a:t>Second level</a:t>
-            </a:r>
-          </a:p>
-          <a:p>
-            <a:pPr lvl="2"/>
-            <a:r>
-              <a:rPr lang="en-US"/>
-              <a:t>Third level</a:t>
-            </a:r>
-          </a:p>
-          <a:p>
-            <a:pPr lvl="3"/>
-            <a:r>
-              <a:rPr lang="en-US"/>
-              <a:t>Fourth level</a:t>
-            </a:r>
-          </a:p>
-          <a:p>
-            <a:pPr lvl="4"/>
-            <a:r>
-              <a:rPr lang="en-US"/>
-              <a:t>Fifth level</a:t>
-            </a:r>
-          </a:p>
-        </p:txBody>
-      </p:sp>
-      <p:sp>
-        <p:nvSpPr>
-          <p:cNvPr id="6" name="Footer Placeholder 5"/>
-          <p:cNvSpPr>
-            <a:spLocks noGrp="1"/>
-          </p:cNvSpPr>
-          <p:nvPr>
-            <p:ph type="ftr" sz="quarter" idx="4"/>
-          </p:nvPr>
-        </p:nvSpPr>
-        <p:spPr>
-          <a:xfrm>
-            <a:off x="0" y="8685213"/>
-            <a:ext cx="2971800" cy="458787"/>
-          </a:xfrm>
-          <a:prstGeom prst="rect">
-            <a:avLst/>
-          </a:prstGeom>
-        </p:spPr>
-        <p:txBody>
-          <a:bodyPr vert="horz" lIns="91440" tIns="45720" rIns="91440" bIns="45720" rtlCol="0" anchor="b"/>
-          <a:lstStyle>
-            <a:lvl1pPr algn="l">
-              <a:defRPr sz="1200"/>
-            </a:lvl1pPr>
-          </a:lstStyle>
-          <a:p>
-            <a:endParaRPr lang="en-US"/>
-          </a:p>
-        </p:txBody>
-      </p:sp>
-      <p:sp>
-        <p:nvSpPr>
-          <p:cNvPr id="7" name="Slide Number Placeholder 6"/>
-          <p:cNvSpPr>
-            <a:spLocks noGrp="1"/>
-          </p:cNvSpPr>
-          <p:nvPr>
-            <p:ph type="sldNum" sz="quarter" idx="5"/>
-          </p:nvPr>
-        </p:nvSpPr>
-        <p:spPr>
-          <a:xfrm>
-            <a:off x="3884613" y="8685213"/>
-            <a:ext cx="2971800" cy="458787"/>
-          </a:xfrm>
-          <a:prstGeom prst="rect">
-            <a:avLst/>
-          </a:prstGeom>
-        </p:spPr>
-        <p:txBody>
-          <a:bodyPr vert="horz" lIns="91440" tIns="45720" rIns="91440" bIns="45720" rtlCol="0" anchor="b"/>
-          <a:lstStyle>
-            <a:lvl1pPr algn="r">
-              <a:defRPr sz="1200"/>
-            </a:lvl1pPr>
-          </a:lstStyle>
-          <a:p>
-            <a:fld id="{CE5E9CC1-C706-0F49-92D6-E571CC5EEA8F}" type="slidenum">
-              <a:rPr lang="en-US"/>
-              <a:t>‹#›</a:t>
-            </a:fld>
-            <a:endParaRPr lang="en-US"/>
-          </a:p>
-        </p:txBody>
-      </p:sp>
     </p:spTree>
     <p:extLst>
       <p:ext uri="{BB962C8B-B14F-4D97-AF65-F5344CB8AC3E}">
-        <p14:creationId xmlns:p14="http://schemas.microsoft.com/office/powerpoint/2010/main" val="1024086991"/>
+        <p14:creationId xmlns:p14="http://schemas.microsoft.com/office/powerpoint/2010/main" val="370262488"/>
       </p:ext>
     </p:extLst>
   </p:cSld>
@@ -513,7 +294,6 @@
               <a:rPr lang="en-US" dirty="0"/>
               <a:t>They know Golden Images and the rename/FROM gap. This meeting is the path: honest today, MVP next, AppTrust as the control plane.</a:t>
             </a:r>
-            <a:endParaRPr lang="en-US" dirty="0"/>
           </a:p>
         </p:txBody>
       </p:sp>
@@ -601,7 +381,6 @@
               <a:rPr lang="en-US" dirty="0"/>
               <a:t>Ask for agreement on the MVP CI contract first. AppTrust is the destination, not the admission ticket.</a:t>
             </a:r>
-            <a:endParaRPr lang="en-US" dirty="0"/>
           </a:p>
         </p:txBody>
       </p:sp>
@@ -689,7 +468,6 @@
               <a:rPr lang="en-US" dirty="0"/>
               <a:t>Acknowledge it works for scoping what is already in Artifactory. Be explicit: this is not something you click in the UI. It is engineering time, edge cases, and no promote hook.</a:t>
             </a:r>
-            <a:endParaRPr lang="en-US" dirty="0"/>
           </a:p>
         </p:txBody>
       </p:sp>
@@ -777,7 +555,6 @@
               <a:rPr lang="en-US" dirty="0"/>
               <a:t>Frame as a program, not a rip-and-replace. Tier 1 is honesty about today. Tier 2 is the recommendation to start. Tier 3 is the enterprise-grade end-state. Next three slides answer their questions in their words.</a:t>
             </a:r>
-            <a:endParaRPr lang="en-US" dirty="0"/>
           </a:p>
         </p:txBody>
       </p:sp>
@@ -865,7 +642,6 @@
               <a:rPr lang="en-US" dirty="0"/>
               <a:t>Read the question as written, then the answer. Do not skip 'pulled through,' 'Acme Golden Image,' or 'another repository.'</a:t>
             </a:r>
-            <a:endParaRPr lang="en-US" dirty="0"/>
           </a:p>
         </p:txBody>
       </p:sp>
@@ -953,7 +729,6 @@
               <a:rPr lang="en-US" dirty="0"/>
               <a:t>Card 1 must name all six signals. Card 3 must answer both halves: discovery MVP and long-term enforcement.</a:t>
             </a:r>
-            <a:endParaRPr lang="en-US" dirty="0"/>
           </a:p>
         </p:txBody>
       </p:sp>
@@ -1041,7 +816,6 @@
               <a:rPr lang="en-US" dirty="0"/>
               <a:t>Answer both verbs in card 1: report on non-Golden vs identify mirrored public origin. Card 2 is a clean no.</a:t>
             </a:r>
-            <a:endParaRPr lang="en-US" dirty="0"/>
           </a:p>
         </p:txBody>
       </p:sp>
@@ -1129,7 +903,6 @@
               <a:rPr lang="en-US" dirty="0"/>
               <a:t>MVP is operational efficiency: stop paying the layer-diff tax on every new image. Historical images without metadata stay in the forensic bucket. Multi-hop: walk parent Evidence or store root_golden_digest on every hop.</a:t>
             </a:r>
-            <a:endParaRPr lang="en-US" dirty="0"/>
           </a:p>
         </p:txBody>
       </p:sp>
@@ -1217,7 +990,6 @@
               <a:rPr lang="en-US" dirty="0"/>
               <a:t>Ideal end-state: Golden Image compliance is a gate, not a spreadsheet. AppTrust reads Evidence at promote. Present → move. Missing → block. If Evidence only names an intermediate, require a walk or root_golden_digest in CI — do not try to recurse the golden catalog inside the gate.</a:t>
             </a:r>
-            <a:endParaRPr lang="en-US" dirty="0"/>
           </a:p>
         </p:txBody>
       </p:sp>
@@ -1305,7 +1077,6 @@
               <a:rPr lang="en-US" dirty="0"/>
               <a:t>Drop the tomjpd2 PreProd dry-run here: payments-api pass, rogue-api fail. Same Evidence the MVP slide just described.</a:t>
             </a:r>
-            <a:endParaRPr lang="en-US" dirty="0"/>
           </a:p>
         </p:txBody>
       </p:sp>
@@ -1378,6 +1149,11 @@
 <file path=ppt/slideMasters/slideMaster1.xml><?xml version="1.0" encoding="utf-8"?>
 <p:sldMaster xmlns:a="http://schemas.openxmlformats.org/drawingml/2006/main" xmlns:r="http://schemas.openxmlformats.org/officeDocument/2006/relationships" xmlns:p="http://schemas.openxmlformats.org/presentationml/2006/main">
   <p:cSld>
+    <p:bg>
+      <p:bgRef idx="1001">
+        <a:schemeClr val="bg1"/>
+      </p:bgRef>
+    </p:bg>
     <p:spTree>
       <p:nvGrpSpPr>
         <p:cNvPr id="1" name=""/>
@@ -1660,6 +1436,7 @@
         <a:solidFill>
           <a:srgbClr val="0D1117"/>
         </a:solidFill>
+        <a:effectLst/>
       </p:bgPr>
     </p:bg>
     <p:spTree>
@@ -1699,11 +1476,11 @@
           </a:bodyPr>
           <a:lstStyle/>
           <a:p>
-            <a:pPr algn="l" indent="0" marL="0">
-              <a:buNone/>
-            </a:pPr>
-            <a:r>
-              <a:rPr lang="en-US" sz="1650" b="1" spc="150" kern="0" dirty="0">
+            <a:pPr marL="0" indent="0" algn="l">
+              <a:buNone/>
+            </a:pPr>
+            <a:r>
+              <a:rPr lang="en-US" sz="1650" b="1" kern="0" spc="150" dirty="0">
                 <a:solidFill>
                   <a:srgbClr val="40C057"/>
                 </a:solidFill>
@@ -1740,7 +1517,7 @@
           </a:bodyPr>
           <a:lstStyle/>
           <a:p>
-            <a:pPr algn="l" indent="0" marL="0">
+            <a:pPr marL="0" indent="0" algn="l">
               <a:lnSpc>
                 <a:spcPct val="80667"/>
               </a:lnSpc>
@@ -1784,7 +1561,7 @@
           </a:bodyPr>
           <a:lstStyle/>
           <a:p>
-            <a:pPr algn="l" indent="0" marL="0">
+            <a:pPr marL="0" indent="0" algn="l">
               <a:buNone/>
             </a:pPr>
             <a:r>
@@ -1825,7 +1602,7 @@
           </a:bodyPr>
           <a:lstStyle/>
           <a:p>
-            <a:pPr algn="l" indent="0" marL="0">
+            <a:pPr marL="0" indent="0" algn="l">
               <a:buNone/>
             </a:pPr>
             <a:r>
@@ -1859,6 +1636,7 @@
         <a:solidFill>
           <a:srgbClr val="0D1117"/>
         </a:solidFill>
+        <a:effectLst/>
       </p:bgPr>
     </p:bg>
     <p:spTree>
@@ -1898,7 +1676,7 @@
           </a:bodyPr>
           <a:lstStyle/>
           <a:p>
-            <a:pPr algn="l" indent="0" marL="0">
+            <a:pPr marL="0" indent="0" algn="l">
               <a:buNone/>
             </a:pPr>
             <a:r>
@@ -1942,6 +1720,13 @@
             <a:prstDash val="solid"/>
           </a:ln>
         </p:spPr>
+        <p:txBody>
+          <a:bodyPr/>
+          <a:lstStyle/>
+          <a:p>
+            <a:endParaRPr lang="en-US"/>
+          </a:p>
+        </p:txBody>
       </p:sp>
       <p:sp>
         <p:nvSpPr>
@@ -1966,11 +1751,11 @@
           </a:bodyPr>
           <a:lstStyle/>
           <a:p>
-            <a:pPr algn="l" indent="0" marL="0">
-              <a:buNone/>
-            </a:pPr>
-            <a:r>
-              <a:rPr lang="en-US" sz="1350" b="1" spc="75" kern="0" dirty="0">
+            <a:pPr marL="0" indent="0" algn="l">
+              <a:buNone/>
+            </a:pPr>
+            <a:r>
+              <a:rPr lang="en-US" sz="1350" b="1" kern="0" spc="75" dirty="0">
                 <a:solidFill>
                   <a:srgbClr val="A0AEC0"/>
                 </a:solidFill>
@@ -2007,7 +1792,7 @@
           </a:bodyPr>
           <a:lstStyle/>
           <a:p>
-            <a:pPr algn="l" indent="0" marL="0">
+            <a:pPr marL="0" indent="0" algn="l">
               <a:lnSpc>
                 <a:spcPct val="110000"/>
               </a:lnSpc>
@@ -2054,6 +1839,13 @@
             <a:prstDash val="solid"/>
           </a:ln>
         </p:spPr>
+        <p:txBody>
+          <a:bodyPr/>
+          <a:lstStyle/>
+          <a:p>
+            <a:endParaRPr lang="en-US"/>
+          </a:p>
+        </p:txBody>
       </p:sp>
       <p:sp>
         <p:nvSpPr>
@@ -2078,11 +1870,11 @@
           </a:bodyPr>
           <a:lstStyle/>
           <a:p>
-            <a:pPr algn="l" indent="0" marL="0">
-              <a:buNone/>
-            </a:pPr>
-            <a:r>
-              <a:rPr lang="en-US" sz="1350" b="1" spc="75" kern="0" dirty="0">
+            <a:pPr marL="0" indent="0" algn="l">
+              <a:buNone/>
+            </a:pPr>
+            <a:r>
+              <a:rPr lang="en-US" sz="1350" b="1" kern="0" spc="75" dirty="0">
                 <a:solidFill>
                   <a:srgbClr val="40C057"/>
                 </a:solidFill>
@@ -2119,7 +1911,7 @@
           </a:bodyPr>
           <a:lstStyle/>
           <a:p>
-            <a:pPr algn="l" indent="0" marL="0">
+            <a:pPr marL="0" indent="0" algn="l">
               <a:lnSpc>
                 <a:spcPct val="110000"/>
               </a:lnSpc>
@@ -2166,6 +1958,13 @@
             <a:prstDash val="solid"/>
           </a:ln>
         </p:spPr>
+        <p:txBody>
+          <a:bodyPr/>
+          <a:lstStyle/>
+          <a:p>
+            <a:endParaRPr lang="en-US"/>
+          </a:p>
+        </p:txBody>
       </p:sp>
       <p:sp>
         <p:nvSpPr>
@@ -2190,11 +1989,11 @@
           </a:bodyPr>
           <a:lstStyle/>
           <a:p>
-            <a:pPr algn="l" indent="0" marL="0">
-              <a:buNone/>
-            </a:pPr>
-            <a:r>
-              <a:rPr lang="en-US" sz="1350" b="1" spc="75" kern="0" dirty="0">
+            <a:pPr marL="0" indent="0" algn="l">
+              <a:buNone/>
+            </a:pPr>
+            <a:r>
+              <a:rPr lang="en-US" sz="1350" b="1" kern="0" spc="75" dirty="0">
                 <a:solidFill>
                   <a:srgbClr val="40C057"/>
                 </a:solidFill>
@@ -2231,7 +2030,7 @@
           </a:bodyPr>
           <a:lstStyle/>
           <a:p>
-            <a:pPr algn="l" indent="0" marL="0">
+            <a:pPr marL="0" indent="0" algn="l">
               <a:lnSpc>
                 <a:spcPct val="110000"/>
               </a:lnSpc>
@@ -2275,7 +2074,7 @@
           </a:bodyPr>
           <a:lstStyle/>
           <a:p>
-            <a:pPr algn="l" indent="0" marL="0">
+            <a:pPr marL="0" indent="0" algn="l">
               <a:buNone/>
             </a:pPr>
             <a:r>
@@ -2309,6 +2108,7 @@
         <a:solidFill>
           <a:srgbClr val="0D1117"/>
         </a:solidFill>
+        <a:effectLst/>
       </p:bgPr>
     </p:bg>
     <p:spTree>
@@ -2348,11 +2148,11 @@
           </a:bodyPr>
           <a:lstStyle/>
           <a:p>
-            <a:pPr algn="l" indent="0" marL="0">
-              <a:buNone/>
-            </a:pPr>
-            <a:r>
-              <a:rPr lang="en-US" sz="1200" b="1" spc="113" kern="0" dirty="0">
+            <a:pPr marL="0" indent="0" algn="l">
+              <a:buNone/>
+            </a:pPr>
+            <a:r>
+              <a:rPr lang="en-US" sz="1200" b="1" kern="0" spc="113" dirty="0">
                 <a:solidFill>
                   <a:srgbClr val="E93838"/>
                 </a:solidFill>
@@ -2389,7 +2189,7 @@
           </a:bodyPr>
           <a:lstStyle/>
           <a:p>
-            <a:pPr algn="l" indent="0" marL="0">
+            <a:pPr marL="0" indent="0" algn="l">
               <a:buNone/>
             </a:pPr>
             <a:r>
@@ -2433,6 +2233,13 @@
             <a:prstDash val="solid"/>
           </a:ln>
         </p:spPr>
+        <p:txBody>
+          <a:bodyPr/>
+          <a:lstStyle/>
+          <a:p>
+            <a:endParaRPr lang="en-US"/>
+          </a:p>
+        </p:txBody>
       </p:sp>
       <p:sp>
         <p:nvSpPr>
@@ -2457,7 +2264,7 @@
           </a:bodyPr>
           <a:lstStyle/>
           <a:p>
-            <a:pPr algn="l" indent="0" marL="0">
+            <a:pPr marL="0" indent="0" algn="l">
               <a:lnSpc>
                 <a:spcPct val="115556"/>
               </a:lnSpc>
@@ -2474,12 +2281,6 @@
               </a:rPr>
               <a:t>The only way to determine lineage </a:t>
             </a:r>
-            <a:pPr algn="l" indent="0" marL="0">
-              <a:lnSpc>
-                <a:spcPct val="115556"/>
-              </a:lnSpc>
-              <a:buNone/>
-            </a:pPr>
             <a:r>
               <a:rPr lang="en-US" sz="1950" b="1" dirty="0">
                 <a:solidFill>
@@ -2491,12 +2292,6 @@
               </a:rPr>
               <a:t>today </a:t>
             </a:r>
-            <a:pPr algn="l" indent="0" marL="0">
-              <a:lnSpc>
-                <a:spcPct val="115556"/>
-              </a:lnSpc>
-              <a:buNone/>
-            </a:pPr>
             <a:r>
               <a:rPr lang="en-US" sz="1950" dirty="0">
                 <a:solidFill>
@@ -2508,12 +2303,6 @@
               </a:rPr>
               <a:t>is comparing image layer diffs (DiffIDs) against a Golden Image catalog. That can reconstruct ancestry after rename. It is also a custom, labor-intensive process — and Artifactory has </a:t>
             </a:r>
-            <a:pPr algn="l" indent="0" marL="0">
-              <a:lnSpc>
-                <a:spcPct val="115556"/>
-              </a:lnSpc>
-              <a:buNone/>
-            </a:pPr>
             <a:r>
               <a:rPr lang="en-US" sz="1950" b="1" dirty="0">
                 <a:solidFill>
@@ -2525,12 +2314,6 @@
               </a:rPr>
               <a:t>no native report </a:t>
             </a:r>
-            <a:pPr algn="l" indent="0" marL="0">
-              <a:lnSpc>
-                <a:spcPct val="115556"/>
-              </a:lnSpc>
-              <a:buNone/>
-            </a:pPr>
             <a:r>
               <a:rPr lang="en-US" sz="1950" dirty="0">
                 <a:solidFill>
@@ -2569,7 +2352,7 @@
           </a:bodyPr>
           <a:lstStyle/>
           <a:p>
-            <a:pPr algn="l" indent="0" marL="0">
+            <a:pPr marL="0" indent="0" algn="l">
               <a:lnSpc>
                 <a:spcPct val="109091"/>
               </a:lnSpc>
@@ -2613,7 +2396,7 @@
           </a:bodyPr>
           <a:lstStyle/>
           <a:p>
-            <a:pPr algn="l" indent="0" marL="0">
+            <a:pPr marL="0" indent="0" algn="l">
               <a:lnSpc>
                 <a:spcPct val="109091"/>
               </a:lnSpc>
@@ -2657,7 +2440,7 @@
           </a:bodyPr>
           <a:lstStyle/>
           <a:p>
-            <a:pPr algn="l" indent="0" marL="0">
+            <a:pPr marL="0" indent="0" algn="l">
               <a:lnSpc>
                 <a:spcPct val="109091"/>
               </a:lnSpc>
@@ -2701,7 +2484,7 @@
           </a:bodyPr>
           <a:lstStyle/>
           <a:p>
-            <a:pPr algn="l" indent="0" marL="0">
+            <a:pPr marL="0" indent="0" algn="l">
               <a:lnSpc>
                 <a:spcPct val="109091"/>
               </a:lnSpc>
@@ -2745,7 +2528,7 @@
           </a:bodyPr>
           <a:lstStyle/>
           <a:p>
-            <a:pPr algn="l" indent="0" marL="0">
+            <a:pPr marL="0" indent="0" algn="l">
               <a:lnSpc>
                 <a:spcPct val="109091"/>
               </a:lnSpc>
@@ -2789,7 +2572,7 @@
           </a:bodyPr>
           <a:lstStyle/>
           <a:p>
-            <a:pPr algn="l" indent="0" marL="0">
+            <a:pPr marL="0" indent="0" algn="l">
               <a:lnSpc>
                 <a:spcPct val="109091"/>
               </a:lnSpc>
@@ -2806,12 +2589,6 @@
               </a:rPr>
               <a:t>Treat "no match" as inconclusive (squash, rebase, </a:t>
             </a:r>
-            <a:pPr algn="l" indent="0" marL="0">
-              <a:lnSpc>
-                <a:spcPct val="109091"/>
-              </a:lnSpc>
-              <a:buNone/>
-            </a:pPr>
             <a:r>
               <a:rPr lang="en-US" sz="1800" dirty="0">
                 <a:solidFill>
@@ -2823,12 +2600,6 @@
               </a:rPr>
               <a:t>FROM scratch </a:t>
             </a:r>
-            <a:pPr algn="l" indent="0" marL="0">
-              <a:lnSpc>
-                <a:spcPct val="109091"/>
-              </a:lnSpc>
-              <a:buNone/>
-            </a:pPr>
             <a:r>
               <a:rPr lang="en-US" sz="1800" dirty="0">
                 <a:solidFill>
@@ -2870,6 +2641,13 @@
             <a:prstDash val="solid"/>
           </a:ln>
         </p:spPr>
+        <p:txBody>
+          <a:bodyPr/>
+          <a:lstStyle/>
+          <a:p>
+            <a:endParaRPr lang="en-US"/>
+          </a:p>
+        </p:txBody>
       </p:sp>
       <p:sp>
         <p:nvSpPr>
@@ -2894,7 +2672,7 @@
           </a:bodyPr>
           <a:lstStyle/>
           <a:p>
-            <a:pPr algn="l" indent="0" marL="0">
+            <a:pPr marL="0" indent="0" algn="l">
               <a:buNone/>
             </a:pPr>
             <a:r>
@@ -2938,6 +2716,13 @@
             <a:prstDash val="solid"/>
           </a:ln>
         </p:spPr>
+        <p:txBody>
+          <a:bodyPr/>
+          <a:lstStyle/>
+          <a:p>
+            <a:endParaRPr lang="en-US"/>
+          </a:p>
+        </p:txBody>
       </p:sp>
       <p:sp>
         <p:nvSpPr>
@@ -2958,11 +2743,11 @@
         </p:spPr>
         <p:txBody>
           <a:bodyPr wrap="square" lIns="25400" tIns="25400" rIns="25400" bIns="25400" rtlCol="0" anchor="t">
-            <a:normAutofit/>
-          </a:bodyPr>
-          <a:lstStyle/>
-          <a:p>
-            <a:pPr algn="l" indent="0" marL="0">
+            <a:normAutofit lnSpcReduction="10000"/>
+          </a:bodyPr>
+          <a:lstStyle/>
+          <a:p>
+            <a:pPr marL="0" indent="0" algn="l">
               <a:buNone/>
             </a:pPr>
             <a:r>
@@ -3006,6 +2791,13 @@
             <a:prstDash val="solid"/>
           </a:ln>
         </p:spPr>
+        <p:txBody>
+          <a:bodyPr/>
+          <a:lstStyle/>
+          <a:p>
+            <a:endParaRPr lang="en-US"/>
+          </a:p>
+        </p:txBody>
       </p:sp>
       <p:sp>
         <p:nvSpPr>
@@ -3026,11 +2818,11 @@
         </p:spPr>
         <p:txBody>
           <a:bodyPr wrap="square" lIns="25400" tIns="25400" rIns="25400" bIns="25400" rtlCol="0" anchor="t">
-            <a:normAutofit/>
-          </a:bodyPr>
-          <a:lstStyle/>
-          <a:p>
-            <a:pPr algn="l" indent="0" marL="0">
+            <a:normAutofit lnSpcReduction="10000"/>
+          </a:bodyPr>
+          <a:lstStyle/>
+          <a:p>
+            <a:pPr marL="0" indent="0" algn="l">
               <a:buNone/>
             </a:pPr>
             <a:r>
@@ -3071,6 +2863,13 @@
             <a:prstDash val="solid"/>
           </a:ln>
         </p:spPr>
+        <p:txBody>
+          <a:bodyPr/>
+          <a:lstStyle/>
+          <a:p>
+            <a:endParaRPr lang="en-US"/>
+          </a:p>
+        </p:txBody>
       </p:sp>
       <p:sp>
         <p:nvSpPr>
@@ -3091,11 +2890,11 @@
         </p:spPr>
         <p:txBody>
           <a:bodyPr wrap="square" lIns="25400" tIns="25400" rIns="25400" bIns="25400" rtlCol="0" anchor="t">
-            <a:normAutofit/>
-          </a:bodyPr>
-          <a:lstStyle/>
-          <a:p>
-            <a:pPr algn="l" indent="0" marL="0">
+            <a:normAutofit lnSpcReduction="10000"/>
+          </a:bodyPr>
+          <a:lstStyle/>
+          <a:p>
+            <a:pPr marL="0" indent="0" algn="l">
               <a:buNone/>
             </a:pPr>
             <a:r>
@@ -3139,6 +2938,13 @@
             <a:prstDash val="solid"/>
           </a:ln>
         </p:spPr>
+        <p:txBody>
+          <a:bodyPr/>
+          <a:lstStyle/>
+          <a:p>
+            <a:endParaRPr lang="en-US"/>
+          </a:p>
+        </p:txBody>
       </p:sp>
       <p:sp>
         <p:nvSpPr>
@@ -3163,7 +2969,7 @@
           </a:bodyPr>
           <a:lstStyle/>
           <a:p>
-            <a:pPr algn="l" indent="0" marL="0">
+            <a:pPr marL="0" indent="0" algn="l">
               <a:buNone/>
             </a:pPr>
             <a:r>
@@ -3204,6 +3010,13 @@
             <a:prstDash val="solid"/>
           </a:ln>
         </p:spPr>
+        <p:txBody>
+          <a:bodyPr/>
+          <a:lstStyle/>
+          <a:p>
+            <a:endParaRPr lang="en-US"/>
+          </a:p>
+        </p:txBody>
       </p:sp>
       <p:sp>
         <p:nvSpPr>
@@ -3224,11 +3037,11 @@
         </p:spPr>
         <p:txBody>
           <a:bodyPr wrap="square" lIns="25400" tIns="25400" rIns="25400" bIns="25400" rtlCol="0" anchor="t">
-            <a:normAutofit/>
-          </a:bodyPr>
-          <a:lstStyle/>
-          <a:p>
-            <a:pPr algn="l" indent="0" marL="0">
+            <a:normAutofit lnSpcReduction="10000"/>
+          </a:bodyPr>
+          <a:lstStyle/>
+          <a:p>
+            <a:pPr marL="0" indent="0" algn="l">
               <a:buNone/>
             </a:pPr>
             <a:r>
@@ -3269,6 +3082,13 @@
             <a:prstDash val="solid"/>
           </a:ln>
         </p:spPr>
+        <p:txBody>
+          <a:bodyPr/>
+          <a:lstStyle/>
+          <a:p>
+            <a:endParaRPr lang="en-US"/>
+          </a:p>
+        </p:txBody>
       </p:sp>
       <p:sp>
         <p:nvSpPr>
@@ -3289,11 +3109,11 @@
         </p:spPr>
         <p:txBody>
           <a:bodyPr wrap="square" lIns="25400" tIns="25400" rIns="25400" bIns="25400" rtlCol="0" anchor="t">
-            <a:normAutofit/>
-          </a:bodyPr>
-          <a:lstStyle/>
-          <a:p>
-            <a:pPr algn="l" indent="0" marL="0">
+            <a:normAutofit lnSpcReduction="10000"/>
+          </a:bodyPr>
+          <a:lstStyle/>
+          <a:p>
+            <a:pPr marL="0" indent="0" algn="l">
               <a:buNone/>
             </a:pPr>
             <a:r>
@@ -3334,7 +3154,7 @@
           </a:bodyPr>
           <a:lstStyle/>
           <a:p>
-            <a:pPr algn="l" indent="0" marL="0">
+            <a:pPr marL="0" indent="0" algn="l">
               <a:buNone/>
             </a:pPr>
             <a:r>
@@ -3375,7 +3195,7 @@
           </a:bodyPr>
           <a:lstStyle/>
           <a:p>
-            <a:pPr algn="l" indent="0" marL="0">
+            <a:pPr marL="0" indent="0" algn="l">
               <a:buNone/>
             </a:pPr>
             <a:r>
@@ -3409,6 +3229,7 @@
         <a:solidFill>
           <a:srgbClr val="0D1117"/>
         </a:solidFill>
+        <a:effectLst/>
       </p:bgPr>
     </p:bg>
     <p:spTree>
@@ -3448,7 +3269,7 @@
           </a:bodyPr>
           <a:lstStyle/>
           <a:p>
-            <a:pPr algn="l" indent="0" marL="0">
+            <a:pPr marL="0" indent="0" algn="l">
               <a:buNone/>
             </a:pPr>
             <a:r>
@@ -3489,7 +3310,7 @@
           </a:bodyPr>
           <a:lstStyle/>
           <a:p>
-            <a:pPr algn="l" indent="0" marL="0">
+            <a:pPr marL="0" indent="0" algn="l">
               <a:buNone/>
             </a:pPr>
             <a:r>
@@ -3533,6 +3354,13 @@
             <a:prstDash val="solid"/>
           </a:ln>
         </p:spPr>
+        <p:txBody>
+          <a:bodyPr/>
+          <a:lstStyle/>
+          <a:p>
+            <a:endParaRPr lang="en-US"/>
+          </a:p>
+        </p:txBody>
       </p:sp>
       <p:sp>
         <p:nvSpPr>
@@ -3557,11 +3385,11 @@
           </a:bodyPr>
           <a:lstStyle/>
           <a:p>
-            <a:pPr algn="l" indent="0" marL="0">
-              <a:buNone/>
-            </a:pPr>
-            <a:r>
-              <a:rPr lang="en-US" sz="1200" b="1" spc="75" kern="0" dirty="0">
+            <a:pPr marL="0" indent="0" algn="l">
+              <a:buNone/>
+            </a:pPr>
+            <a:r>
+              <a:rPr lang="en-US" sz="1200" b="1" kern="0" spc="75" dirty="0">
                 <a:solidFill>
                   <a:srgbClr val="A0AEC0"/>
                 </a:solidFill>
@@ -3598,7 +3426,7 @@
           </a:bodyPr>
           <a:lstStyle/>
           <a:p>
-            <a:pPr algn="l" indent="0" marL="0">
+            <a:pPr marL="0" indent="0" algn="l">
               <a:buNone/>
             </a:pPr>
             <a:r>
@@ -3639,7 +3467,7 @@
           </a:bodyPr>
           <a:lstStyle/>
           <a:p>
-            <a:pPr algn="l" indent="0" marL="0">
+            <a:pPr marL="0" indent="0" algn="l">
               <a:lnSpc>
                 <a:spcPct val="110000"/>
               </a:lnSpc>
@@ -3686,6 +3514,13 @@
             <a:prstDash val="solid"/>
           </a:ln>
         </p:spPr>
+        <p:txBody>
+          <a:bodyPr/>
+          <a:lstStyle/>
+          <a:p>
+            <a:endParaRPr lang="en-US"/>
+          </a:p>
+        </p:txBody>
       </p:sp>
       <p:sp>
         <p:nvSpPr>
@@ -3710,11 +3545,11 @@
           </a:bodyPr>
           <a:lstStyle/>
           <a:p>
-            <a:pPr algn="l" indent="0" marL="0">
-              <a:buNone/>
-            </a:pPr>
-            <a:r>
-              <a:rPr lang="en-US" sz="1200" b="1" spc="75" kern="0" dirty="0">
+            <a:pPr marL="0" indent="0" algn="l">
+              <a:buNone/>
+            </a:pPr>
+            <a:r>
+              <a:rPr lang="en-US" sz="1200" b="1" kern="0" spc="75" dirty="0">
                 <a:solidFill>
                   <a:srgbClr val="40C057"/>
                 </a:solidFill>
@@ -3751,7 +3586,7 @@
           </a:bodyPr>
           <a:lstStyle/>
           <a:p>
-            <a:pPr algn="l" indent="0" marL="0">
+            <a:pPr marL="0" indent="0" algn="l">
               <a:buNone/>
             </a:pPr>
             <a:r>
@@ -3792,7 +3627,7 @@
           </a:bodyPr>
           <a:lstStyle/>
           <a:p>
-            <a:pPr algn="l" indent="0" marL="0">
+            <a:pPr marL="0" indent="0" algn="l">
               <a:lnSpc>
                 <a:spcPct val="110000"/>
               </a:lnSpc>
@@ -3809,12 +3644,6 @@
               </a:rPr>
               <a:t>Use </a:t>
             </a:r>
-            <a:pPr algn="l" indent="0" marL="0">
-              <a:lnSpc>
-                <a:spcPct val="110000"/>
-              </a:lnSpc>
-              <a:buNone/>
-            </a:pPr>
             <a:r>
               <a:rPr lang="en-US" sz="1650" b="1" dirty="0">
                 <a:solidFill>
@@ -3826,12 +3655,6 @@
               </a:rPr>
               <a:t>Evidence </a:t>
             </a:r>
-            <a:pPr algn="l" indent="0" marL="0">
-              <a:lnSpc>
-                <a:spcPct val="110000"/>
-              </a:lnSpc>
-              <a:buNone/>
-            </a:pPr>
             <a:r>
               <a:rPr lang="en-US" sz="1650" dirty="0">
                 <a:solidFill>
@@ -3843,12 +3666,6 @@
               </a:rPr>
               <a:t>and </a:t>
             </a:r>
-            <a:pPr algn="l" indent="0" marL="0">
-              <a:lnSpc>
-                <a:spcPct val="110000"/>
-              </a:lnSpc>
-              <a:buNone/>
-            </a:pPr>
             <a:r>
               <a:rPr lang="en-US" sz="1650" b="1" dirty="0">
                 <a:solidFill>
@@ -3860,12 +3677,6 @@
               </a:rPr>
               <a:t>Build Info </a:t>
             </a:r>
-            <a:pPr algn="l" indent="0" marL="0">
-              <a:lnSpc>
-                <a:spcPct val="110000"/>
-              </a:lnSpc>
-              <a:buNone/>
-            </a:pPr>
             <a:r>
               <a:rPr lang="en-US" sz="1650" dirty="0">
                 <a:solidFill>
@@ -3907,6 +3718,13 @@
             <a:prstDash val="solid"/>
           </a:ln>
         </p:spPr>
+        <p:txBody>
+          <a:bodyPr/>
+          <a:lstStyle/>
+          <a:p>
+            <a:endParaRPr lang="en-US"/>
+          </a:p>
+        </p:txBody>
       </p:sp>
       <p:sp>
         <p:nvSpPr>
@@ -3931,11 +3749,11 @@
           </a:bodyPr>
           <a:lstStyle/>
           <a:p>
-            <a:pPr algn="l" indent="0" marL="0">
-              <a:buNone/>
-            </a:pPr>
-            <a:r>
-              <a:rPr lang="en-US" sz="1200" b="1" spc="75" kern="0" dirty="0">
+            <a:pPr marL="0" indent="0" algn="l">
+              <a:buNone/>
+            </a:pPr>
+            <a:r>
+              <a:rPr lang="en-US" sz="1200" b="1" kern="0" spc="75" dirty="0">
                 <a:solidFill>
                   <a:srgbClr val="40C057"/>
                 </a:solidFill>
@@ -3972,7 +3790,7 @@
           </a:bodyPr>
           <a:lstStyle/>
           <a:p>
-            <a:pPr algn="l" indent="0" marL="0">
+            <a:pPr marL="0" indent="0" algn="l">
               <a:buNone/>
             </a:pPr>
             <a:r>
@@ -4013,7 +3831,7 @@
           </a:bodyPr>
           <a:lstStyle/>
           <a:p>
-            <a:pPr algn="l" indent="0" marL="0">
+            <a:pPr marL="0" indent="0" algn="l">
               <a:lnSpc>
                 <a:spcPct val="110000"/>
               </a:lnSpc>
@@ -4030,12 +3848,6 @@
               </a:rPr>
               <a:t>AppTrust </a:t>
             </a:r>
-            <a:pPr algn="l" indent="0" marL="0">
-              <a:lnSpc>
-                <a:spcPct val="110000"/>
-              </a:lnSpc>
-              <a:buNone/>
-            </a:pPr>
             <a:r>
               <a:rPr lang="en-US" sz="1650" dirty="0">
                 <a:solidFill>
@@ -4074,7 +3886,7 @@
           </a:bodyPr>
           <a:lstStyle/>
           <a:p>
-            <a:pPr algn="l" indent="0" marL="0">
+            <a:pPr marL="0" indent="0" algn="l">
               <a:buNone/>
             </a:pPr>
             <a:r>
@@ -4108,6 +3920,7 @@
         <a:solidFill>
           <a:srgbClr val="0D1117"/>
         </a:solidFill>
+        <a:effectLst/>
       </p:bgPr>
     </p:bg>
     <p:spTree>
@@ -4147,7 +3960,7 @@
           </a:bodyPr>
           <a:lstStyle/>
           <a:p>
-            <a:pPr algn="l" indent="0" marL="0">
+            <a:pPr marL="0" indent="0" algn="l">
               <a:buNone/>
             </a:pPr>
             <a:r>
@@ -4191,6 +4004,13 @@
             <a:prstDash val="solid"/>
           </a:ln>
         </p:spPr>
+        <p:txBody>
+          <a:bodyPr/>
+          <a:lstStyle/>
+          <a:p>
+            <a:endParaRPr lang="en-US"/>
+          </a:p>
+        </p:txBody>
       </p:sp>
       <p:sp>
         <p:nvSpPr>
@@ -4215,7 +4035,7 @@
           </a:bodyPr>
           <a:lstStyle/>
           <a:p>
-            <a:pPr algn="l" indent="0" marL="0">
+            <a:pPr marL="0" indent="0" algn="l">
               <a:buNone/>
             </a:pPr>
             <a:r>
@@ -4256,7 +4076,7 @@
           </a:bodyPr>
           <a:lstStyle/>
           <a:p>
-            <a:pPr algn="l" indent="0" marL="0">
+            <a:pPr marL="0" indent="0" algn="l">
               <a:lnSpc>
                 <a:spcPct val="109615"/>
               </a:lnSpc>
@@ -4273,12 +4093,6 @@
               </a:rPr>
               <a:t>Today: digest, ordered layers, and whatever Build Info or Evidence was already published. Artifactory does </a:t>
             </a:r>
-            <a:pPr algn="l" indent="0" marL="0">
-              <a:lnSpc>
-                <a:spcPct val="109615"/>
-              </a:lnSpc>
-              <a:buNone/>
-            </a:pPr>
             <a:r>
               <a:rPr lang="en-US" sz="1425" b="1" dirty="0">
                 <a:solidFill>
@@ -4290,12 +4104,6 @@
               </a:rPr>
               <a:t>not </a:t>
             </a:r>
-            <a:pPr algn="l" indent="0" marL="0">
-              <a:lnSpc>
-                <a:spcPct val="109615"/>
-              </a:lnSpc>
-              <a:buNone/>
-            </a:pPr>
             <a:r>
               <a:rPr lang="en-US" sz="1425" dirty="0">
                 <a:solidFill>
@@ -4307,12 +4115,6 @@
               </a:rPr>
               <a:t>retain the original </a:t>
             </a:r>
-            <a:pPr algn="l" indent="0" marL="0">
-              <a:lnSpc>
-                <a:spcPct val="109615"/>
-              </a:lnSpc>
-              <a:buNone/>
-            </a:pPr>
             <a:r>
               <a:rPr lang="en-US" sz="1425" dirty="0">
                 <a:solidFill>
@@ -4324,12 +4126,6 @@
               </a:rPr>
               <a:t>FROM </a:t>
             </a:r>
-            <a:pPr algn="l" indent="0" marL="0">
-              <a:lnSpc>
-                <a:spcPct val="109615"/>
-              </a:lnSpc>
-              <a:buNone/>
-            </a:pPr>
             <a:r>
               <a:rPr lang="en-US" sz="1425" dirty="0">
                 <a:solidFill>
@@ -4371,6 +4167,13 @@
             <a:prstDash val="solid"/>
           </a:ln>
         </p:spPr>
+        <p:txBody>
+          <a:bodyPr/>
+          <a:lstStyle/>
+          <a:p>
+            <a:endParaRPr lang="en-US"/>
+          </a:p>
+        </p:txBody>
       </p:sp>
       <p:sp>
         <p:nvSpPr>
@@ -4395,7 +4198,7 @@
           </a:bodyPr>
           <a:lstStyle/>
           <a:p>
-            <a:pPr algn="l" indent="0" marL="0">
+            <a:pPr marL="0" indent="0" algn="l">
               <a:buNone/>
             </a:pPr>
             <a:r>
@@ -4436,7 +4239,7 @@
           </a:bodyPr>
           <a:lstStyle/>
           <a:p>
-            <a:pPr algn="l" indent="0" marL="0">
+            <a:pPr marL="0" indent="0" algn="l">
               <a:lnSpc>
                 <a:spcPct val="109615"/>
               </a:lnSpc>
@@ -4453,12 +4256,6 @@
               </a:rPr>
               <a:t>Yes </a:t>
             </a:r>
-            <a:pPr algn="l" indent="0" marL="0">
-              <a:lnSpc>
-                <a:spcPct val="109615"/>
-              </a:lnSpc>
-              <a:buNone/>
-            </a:pPr>
             <a:r>
               <a:rPr lang="en-US" sz="1425" dirty="0">
                 <a:solidFill>
@@ -4470,12 +4267,6 @@
               </a:rPr>
               <a:t>for renamed or retagged images in Artifactory — digest and layer chain do not change, so a Golden layer prefix can still match. </a:t>
             </a:r>
-            <a:pPr algn="l" indent="0" marL="0">
-              <a:lnSpc>
-                <a:spcPct val="109615"/>
-              </a:lnSpc>
-              <a:buNone/>
-            </a:pPr>
             <a:r>
               <a:rPr lang="en-US" sz="1425" b="1" dirty="0">
                 <a:solidFill>
@@ -4487,12 +4278,6 @@
               </a:rPr>
               <a:t>Partially </a:t>
             </a:r>
-            <a:pPr algn="l" indent="0" marL="0">
-              <a:lnSpc>
-                <a:spcPct val="109615"/>
-              </a:lnSpc>
-              <a:buNone/>
-            </a:pPr>
             <a:r>
               <a:rPr lang="en-US" sz="1425" dirty="0">
                 <a:solidFill>
@@ -4534,6 +4319,13 @@
             <a:prstDash val="solid"/>
           </a:ln>
         </p:spPr>
+        <p:txBody>
+          <a:bodyPr/>
+          <a:lstStyle/>
+          <a:p>
+            <a:endParaRPr lang="en-US"/>
+          </a:p>
+        </p:txBody>
       </p:sp>
       <p:sp>
         <p:nvSpPr>
@@ -4558,7 +4350,7 @@
           </a:bodyPr>
           <a:lstStyle/>
           <a:p>
-            <a:pPr algn="l" indent="0" marL="0">
+            <a:pPr marL="0" indent="0" algn="l">
               <a:buNone/>
             </a:pPr>
             <a:r>
@@ -4599,7 +4391,7 @@
           </a:bodyPr>
           <a:lstStyle/>
           <a:p>
-            <a:pPr algn="l" indent="0" marL="0">
+            <a:pPr marL="0" indent="0" algn="l">
               <a:lnSpc>
                 <a:spcPct val="109615"/>
               </a:lnSpc>
@@ -4616,12 +4408,6 @@
               </a:rPr>
               <a:t>Acme should expect </a:t>
             </a:r>
-            <a:pPr algn="l" indent="0" marL="0">
-              <a:lnSpc>
-                <a:spcPct val="109615"/>
-              </a:lnSpc>
-              <a:buNone/>
-            </a:pPr>
             <a:r>
               <a:rPr lang="en-US" sz="1425" b="1" dirty="0">
                 <a:solidFill>
@@ -4633,12 +4419,6 @@
               </a:rPr>
               <a:t>no queryable provenance </a:t>
             </a:r>
-            <a:pPr algn="l" indent="0" marL="0">
-              <a:lnSpc>
-                <a:spcPct val="109615"/>
-              </a:lnSpc>
-              <a:buNone/>
-            </a:pPr>
             <a:r>
               <a:rPr lang="en-US" sz="1425" dirty="0">
                 <a:solidFill>
@@ -4670,6 +4450,7 @@
         <a:solidFill>
           <a:srgbClr val="0D1117"/>
         </a:solidFill>
+        <a:effectLst/>
       </p:bgPr>
     </p:bg>
     <p:spTree>
@@ -4709,7 +4490,7 @@
           </a:bodyPr>
           <a:lstStyle/>
           <a:p>
-            <a:pPr algn="l" indent="0" marL="0">
+            <a:pPr marL="0" indent="0" algn="l">
               <a:buNone/>
             </a:pPr>
             <a:r>
@@ -4753,6 +4534,13 @@
             <a:prstDash val="solid"/>
           </a:ln>
         </p:spPr>
+        <p:txBody>
+          <a:bodyPr/>
+          <a:lstStyle/>
+          <a:p>
+            <a:endParaRPr lang="en-US"/>
+          </a:p>
+        </p:txBody>
       </p:sp>
       <p:sp>
         <p:nvSpPr>
@@ -4777,7 +4565,7 @@
           </a:bodyPr>
           <a:lstStyle/>
           <a:p>
-            <a:pPr algn="l" indent="0" marL="0">
+            <a:pPr marL="0" indent="0" algn="l">
               <a:buNone/>
             </a:pPr>
             <a:r>
@@ -4818,7 +4606,7 @@
           </a:bodyPr>
           <a:lstStyle/>
           <a:p>
-            <a:pPr algn="l" indent="0" marL="0">
+            <a:pPr marL="0" indent="0" algn="l">
               <a:lnSpc>
                 <a:spcPct val="109615"/>
               </a:lnSpc>
@@ -4835,12 +4623,6 @@
               </a:rPr>
               <a:t>Partially — signal by signal. </a:t>
             </a:r>
-            <a:pPr algn="l" indent="0" marL="0">
-              <a:lnSpc>
-                <a:spcPct val="109615"/>
-              </a:lnSpc>
-              <a:buNone/>
-            </a:pPr>
             <a:r>
               <a:rPr lang="en-US" sz="1425" dirty="0">
                 <a:solidFill>
@@ -4882,6 +4664,13 @@
             <a:prstDash val="solid"/>
           </a:ln>
         </p:spPr>
+        <p:txBody>
+          <a:bodyPr/>
+          <a:lstStyle/>
+          <a:p>
+            <a:endParaRPr lang="en-US"/>
+          </a:p>
+        </p:txBody>
       </p:sp>
       <p:sp>
         <p:nvSpPr>
@@ -4906,7 +4695,7 @@
           </a:bodyPr>
           <a:lstStyle/>
           <a:p>
-            <a:pPr algn="l" indent="0" marL="0">
+            <a:pPr marL="0" indent="0" algn="l">
               <a:buNone/>
             </a:pPr>
             <a:r>
@@ -4947,7 +4736,7 @@
           </a:bodyPr>
           <a:lstStyle/>
           <a:p>
-            <a:pPr algn="l" indent="0" marL="0">
+            <a:pPr marL="0" indent="0" algn="l">
               <a:lnSpc>
                 <a:spcPct val="109615"/>
               </a:lnSpc>
@@ -4964,12 +4753,6 @@
               </a:rPr>
               <a:t>Digest-pinned FROM. Build Info on every </a:t>
             </a:r>
-            <a:pPr algn="l" indent="0" marL="0">
-              <a:lnSpc>
-                <a:spcPct val="109615"/>
-              </a:lnSpc>
-              <a:buNone/>
-            </a:pPr>
             <a:r>
               <a:rPr lang="en-US" sz="1425" dirty="0">
                 <a:solidFill>
@@ -4981,12 +4764,6 @@
               </a:rPr>
               <a:t>jf docker push </a:t>
             </a:r>
-            <a:pPr algn="l" indent="0" marL="0">
-              <a:lnSpc>
-                <a:spcPct val="109615"/>
-              </a:lnSpc>
-              <a:buNone/>
-            </a:pPr>
             <a:r>
               <a:rPr lang="en-US" sz="1425" dirty="0">
                 <a:solidFill>
@@ -4998,12 +4775,6 @@
               </a:rPr>
               <a:t>/ build-publish. Signed Evidence on the image digest: child digest, immediate base name + digest, preferably </a:t>
             </a:r>
-            <a:pPr algn="l" indent="0" marL="0">
-              <a:lnSpc>
-                <a:spcPct val="109615"/>
-              </a:lnSpc>
-              <a:buNone/>
-            </a:pPr>
             <a:r>
               <a:rPr lang="en-US" sz="1425" dirty="0">
                 <a:solidFill>
@@ -5015,12 +4786,6 @@
               </a:rPr>
               <a:t>root_golden_digest </a:t>
             </a:r>
-            <a:pPr algn="l" indent="0" marL="0">
-              <a:lnSpc>
-                <a:spcPct val="109615"/>
-              </a:lnSpc>
-              <a:buNone/>
-            </a:pPr>
             <a:r>
               <a:rPr lang="en-US" sz="1425" dirty="0">
                 <a:solidFill>
@@ -5062,6 +4827,13 @@
             <a:prstDash val="solid"/>
           </a:ln>
         </p:spPr>
+        <p:txBody>
+          <a:bodyPr/>
+          <a:lstStyle/>
+          <a:p>
+            <a:endParaRPr lang="en-US"/>
+          </a:p>
+        </p:txBody>
       </p:sp>
       <p:sp>
         <p:nvSpPr>
@@ -5086,7 +4858,7 @@
           </a:bodyPr>
           <a:lstStyle/>
           <a:p>
-            <a:pPr algn="l" indent="0" marL="0">
+            <a:pPr marL="0" indent="0" algn="l">
               <a:buNone/>
             </a:pPr>
             <a:r>
@@ -5127,7 +4899,7 @@
           </a:bodyPr>
           <a:lstStyle/>
           <a:p>
-            <a:pPr algn="l" indent="0" marL="0">
+            <a:pPr marL="0" indent="0" algn="l">
               <a:lnSpc>
                 <a:spcPct val="109615"/>
               </a:lnSpc>
@@ -5144,12 +4916,6 @@
               </a:rPr>
               <a:t>Current-state discovery (MVP): </a:t>
             </a:r>
-            <a:pPr algn="l" indent="0" marL="0">
-              <a:lnSpc>
-                <a:spcPct val="109615"/>
-              </a:lnSpc>
-              <a:buNone/>
-            </a:pPr>
             <a:r>
               <a:rPr lang="en-US" sz="1425" dirty="0">
                 <a:solidFill>
@@ -5161,12 +4927,6 @@
               </a:rPr>
               <a:t>Evidence + Build Info on new publishes so Artifactory can be queried; layer-diff only to scope historical images that have no metadata. </a:t>
             </a:r>
-            <a:pPr algn="l" indent="0" marL="0">
-              <a:lnSpc>
-                <a:spcPct val="109615"/>
-              </a:lnSpc>
-              <a:buNone/>
-            </a:pPr>
             <a:r>
               <a:rPr lang="en-US" sz="1425" b="1" dirty="0">
                 <a:solidFill>
@@ -5178,12 +4938,6 @@
               </a:rPr>
               <a:t>Long-term governance and enforcement: </a:t>
             </a:r>
-            <a:pPr algn="l" indent="0" marL="0">
-              <a:lnSpc>
-                <a:spcPct val="109615"/>
-              </a:lnSpc>
-              <a:buNone/>
-            </a:pPr>
             <a:r>
               <a:rPr lang="en-US" sz="1425" dirty="0">
                 <a:solidFill>
@@ -5215,6 +4969,7 @@
         <a:solidFill>
           <a:srgbClr val="0D1117"/>
         </a:solidFill>
+        <a:effectLst/>
       </p:bgPr>
     </p:bg>
     <p:spTree>
@@ -5254,7 +5009,7 @@
           </a:bodyPr>
           <a:lstStyle/>
           <a:p>
-            <a:pPr algn="l" indent="0" marL="0">
+            <a:pPr marL="0" indent="0" algn="l">
               <a:buNone/>
             </a:pPr>
             <a:r>
@@ -5298,6 +5053,13 @@
             <a:prstDash val="solid"/>
           </a:ln>
         </p:spPr>
+        <p:txBody>
+          <a:bodyPr/>
+          <a:lstStyle/>
+          <a:p>
+            <a:endParaRPr lang="en-US"/>
+          </a:p>
+        </p:txBody>
       </p:sp>
       <p:sp>
         <p:nvSpPr>
@@ -5322,7 +5084,7 @@
           </a:bodyPr>
           <a:lstStyle/>
           <a:p>
-            <a:pPr algn="l" indent="0" marL="0">
+            <a:pPr marL="0" indent="0" algn="l">
               <a:buNone/>
             </a:pPr>
             <a:r>
@@ -5363,7 +5125,7 @@
           </a:bodyPr>
           <a:lstStyle/>
           <a:p>
-            <a:pPr algn="l" indent="0" marL="0">
+            <a:pPr marL="0" indent="0" algn="l">
               <a:lnSpc>
                 <a:spcPct val="120000"/>
               </a:lnSpc>
@@ -5380,12 +5142,6 @@
               </a:rPr>
               <a:t>Partially. </a:t>
             </a:r>
-            <a:pPr algn="l" indent="0" marL="0">
-              <a:lnSpc>
-                <a:spcPct val="120000"/>
-              </a:lnSpc>
-              <a:buNone/>
-            </a:pPr>
             <a:r>
               <a:rPr lang="en-US" sz="1575" dirty="0">
                 <a:solidFill>
@@ -5427,6 +5183,13 @@
             <a:prstDash val="solid"/>
           </a:ln>
         </p:spPr>
+        <p:txBody>
+          <a:bodyPr/>
+          <a:lstStyle/>
+          <a:p>
+            <a:endParaRPr lang="en-US"/>
+          </a:p>
+        </p:txBody>
       </p:sp>
       <p:sp>
         <p:nvSpPr>
@@ -5451,7 +5214,7 @@
           </a:bodyPr>
           <a:lstStyle/>
           <a:p>
-            <a:pPr algn="l" indent="0" marL="0">
+            <a:pPr marL="0" indent="0" algn="l">
               <a:buNone/>
             </a:pPr>
             <a:r>
@@ -5492,7 +5255,7 @@
           </a:bodyPr>
           <a:lstStyle/>
           <a:p>
-            <a:pPr algn="l" indent="0" marL="0">
+            <a:pPr marL="0" indent="0" algn="l">
               <a:lnSpc>
                 <a:spcPct val="120000"/>
               </a:lnSpc>
@@ -5509,12 +5272,6 @@
               </a:rPr>
               <a:t>No </a:t>
             </a:r>
-            <a:pPr algn="l" indent="0" marL="0">
-              <a:lnSpc>
-                <a:spcPct val="120000"/>
-              </a:lnSpc>
-              <a:buNone/>
-            </a:pPr>
             <a:r>
               <a:rPr lang="en-US" sz="1575" dirty="0">
                 <a:solidFill>
@@ -5546,6 +5303,7 @@
         <a:solidFill>
           <a:srgbClr val="0D1117"/>
         </a:solidFill>
+        <a:effectLst/>
       </p:bgPr>
     </p:bg>
     <p:spTree>
@@ -5585,7 +5343,7 @@
           </a:bodyPr>
           <a:lstStyle/>
           <a:p>
-            <a:pPr algn="l" indent="0" marL="0">
+            <a:pPr marL="0" indent="0" algn="l">
               <a:buNone/>
             </a:pPr>
             <a:r>
@@ -5626,7 +5384,7 @@
           </a:bodyPr>
           <a:lstStyle/>
           <a:p>
-            <a:pPr algn="l" indent="0" marL="0">
+            <a:pPr marL="0" indent="0" algn="l">
               <a:buNone/>
             </a:pPr>
             <a:r>
@@ -5667,7 +5425,7 @@
           </a:bodyPr>
           <a:lstStyle/>
           <a:p>
-            <a:pPr algn="l" indent="0" marL="0">
+            <a:pPr marL="0" indent="0" algn="l">
               <a:lnSpc>
                 <a:spcPct val="109091"/>
               </a:lnSpc>
@@ -5711,7 +5469,7 @@
           </a:bodyPr>
           <a:lstStyle/>
           <a:p>
-            <a:pPr algn="l" indent="0" marL="0">
+            <a:pPr marL="0" indent="0" algn="l">
               <a:lnSpc>
                 <a:spcPct val="109091"/>
               </a:lnSpc>
@@ -5728,7 +5486,67 @@
               </a:rPr>
               <a:t>Build Info </a:t>
             </a:r>
-            <a:pPr algn="l" indent="0" marL="0">
+            <a:r>
+              <a:rPr lang="en-US" sz="1800" dirty="0">
+                <a:solidFill>
+                  <a:srgbClr val="FFFFFF"/>
+                </a:solidFill>
+                <a:latin typeface="Open Sans" pitchFamily="34" charset="0"/>
+                <a:ea typeface="Open Sans" pitchFamily="34" charset="-122"/>
+                <a:cs typeface="Open Sans" pitchFamily="34" charset="-120"/>
+              </a:rPr>
+              <a:t>— publish with </a:t>
+            </a:r>
+            <a:r>
+              <a:rPr lang="en-US" sz="1500" dirty="0">
+                <a:solidFill>
+                  <a:srgbClr val="FFFFFF"/>
+                </a:solidFill>
+                <a:latin typeface="Overpass Mono" pitchFamily="34" charset="0"/>
+                <a:ea typeface="Overpass Mono" pitchFamily="34" charset="-122"/>
+                <a:cs typeface="Overpass Mono" pitchFamily="34" charset="-120"/>
+              </a:rPr>
+              <a:t>jf docker push --build-name/--build-number </a:t>
+            </a:r>
+            <a:r>
+              <a:rPr lang="en-US" sz="1800" dirty="0">
+                <a:solidFill>
+                  <a:srgbClr val="FFFFFF"/>
+                </a:solidFill>
+                <a:latin typeface="Open Sans" pitchFamily="34" charset="0"/>
+                <a:ea typeface="Open Sans" pitchFamily="34" charset="-122"/>
+                <a:cs typeface="Open Sans" pitchFamily="34" charset="-120"/>
+              </a:rPr>
+              <a:t>so the image is tied to a build, not only a tag</a:t>
+            </a:r>
+            <a:endParaRPr lang="en-US" sz="1800" dirty="0"/>
+          </a:p>
+        </p:txBody>
+      </p:sp>
+      <p:sp>
+        <p:nvSpPr>
+          <p:cNvPr id="6" name="Text 4"/>
+          <p:cNvSpPr/>
+          <p:nvPr/>
+        </p:nvSpPr>
+        <p:spPr>
+          <a:xfrm>
+            <a:off x="1143000" y="5672138"/>
+            <a:ext cx="191839" cy="381000"/>
+          </a:xfrm>
+          <a:prstGeom prst="rect">
+            <a:avLst/>
+          </a:prstGeom>
+          <a:noFill/>
+          <a:ln/>
+        </p:spPr>
+        <p:txBody>
+          <a:bodyPr wrap="square" lIns="25400" tIns="25400" rIns="25400" bIns="25400" rtlCol="0" anchor="t">
+            <a:normAutofit/>
+          </a:bodyPr>
+          <a:lstStyle/>
+          <a:p>
+            <a:pPr marL="0" indent="0" algn="l">
               <a:lnSpc>
                 <a:spcPct val="109091"/>
               </a:lnSpc>
@@ -5737,32 +5555,97 @@
             <a:r>
               <a:rPr lang="en-US" sz="1800" dirty="0">
                 <a:solidFill>
-                  <a:srgbClr val="FFFFFF"/>
-                </a:solidFill>
-                <a:latin typeface="Open Sans" pitchFamily="34" charset="0"/>
-                <a:ea typeface="Open Sans" pitchFamily="34" charset="-122"/>
-                <a:cs typeface="Open Sans" pitchFamily="34" charset="-120"/>
-              </a:rPr>
-              <a:t>— publish with </a:t>
-            </a:r>
-            <a:pPr algn="l" indent="0" marL="0">
+                  <a:srgbClr val="40C057"/>
+                </a:solidFill>
+                <a:latin typeface="Open Sans" pitchFamily="34" charset="0"/>
+                <a:ea typeface="Open Sans" pitchFamily="34" charset="-122"/>
+                <a:cs typeface="Open Sans" pitchFamily="34" charset="-120"/>
+              </a:rPr>
+              <a:t>▪</a:t>
+            </a:r>
+            <a:endParaRPr lang="en-US" sz="1800" dirty="0"/>
+          </a:p>
+        </p:txBody>
+      </p:sp>
+      <p:sp>
+        <p:nvSpPr>
+          <p:cNvPr id="7" name="Text 5"/>
+          <p:cNvSpPr/>
+          <p:nvPr/>
+        </p:nvSpPr>
+        <p:spPr>
+          <a:xfrm>
+            <a:off x="1391989" y="5672138"/>
+            <a:ext cx="7670627" cy="723900"/>
+          </a:xfrm>
+          <a:prstGeom prst="rect">
+            <a:avLst/>
+          </a:prstGeom>
+          <a:noFill/>
+          <a:ln/>
+        </p:spPr>
+        <p:txBody>
+          <a:bodyPr wrap="square" lIns="25400" tIns="25400" rIns="25400" bIns="25400" rtlCol="0" anchor="t">
+            <a:normAutofit/>
+          </a:bodyPr>
+          <a:lstStyle/>
+          <a:p>
+            <a:pPr marL="0" indent="0" algn="l">
               <a:lnSpc>
                 <a:spcPct val="109091"/>
               </a:lnSpc>
               <a:buNone/>
             </a:pPr>
             <a:r>
-              <a:rPr lang="en-US" sz="1500" dirty="0">
+              <a:rPr lang="en-US" sz="1800" b="1" dirty="0">
                 <a:solidFill>
                   <a:srgbClr val="FFFFFF"/>
                 </a:solidFill>
-                <a:latin typeface="Overpass Mono" pitchFamily="34" charset="0"/>
-                <a:ea typeface="Overpass Mono" pitchFamily="34" charset="-122"/>
-                <a:cs typeface="Overpass Mono" pitchFamily="34" charset="-120"/>
-              </a:rPr>
-              <a:t>jf docker push --build-name/--build-number </a:t>
-            </a:r>
-            <a:pPr algn="l" indent="0" marL="0">
+                <a:latin typeface="Open Sans" pitchFamily="34" charset="0"/>
+                <a:ea typeface="Open Sans" pitchFamily="34" charset="-122"/>
+                <a:cs typeface="Open Sans" pitchFamily="34" charset="-120"/>
+              </a:rPr>
+              <a:t>Evidence </a:t>
+            </a:r>
+            <a:r>
+              <a:rPr lang="en-US" sz="1800" dirty="0">
+                <a:solidFill>
+                  <a:srgbClr val="FFFFFF"/>
+                </a:solidFill>
+                <a:latin typeface="Open Sans" pitchFamily="34" charset="0"/>
+                <a:ea typeface="Open Sans" pitchFamily="34" charset="-122"/>
+                <a:cs typeface="Open Sans" pitchFamily="34" charset="-120"/>
+              </a:rPr>
+              <a:t>— signed lineage on the digest: child image, immediate base, preferably root Golden digest</a:t>
+            </a:r>
+            <a:endParaRPr lang="en-US" sz="1800" dirty="0"/>
+          </a:p>
+        </p:txBody>
+      </p:sp>
+      <p:sp>
+        <p:nvSpPr>
+          <p:cNvPr id="8" name="Text 6"/>
+          <p:cNvSpPr/>
+          <p:nvPr/>
+        </p:nvSpPr>
+        <p:spPr>
+          <a:xfrm>
+            <a:off x="1143000" y="6586538"/>
+            <a:ext cx="191839" cy="381000"/>
+          </a:xfrm>
+          <a:prstGeom prst="rect">
+            <a:avLst/>
+          </a:prstGeom>
+          <a:noFill/>
+          <a:ln/>
+        </p:spPr>
+        <p:txBody>
+          <a:bodyPr wrap="square" lIns="25400" tIns="25400" rIns="25400" bIns="25400" rtlCol="0" anchor="t">
+            <a:normAutofit/>
+          </a:bodyPr>
+          <a:lstStyle/>
+          <a:p>
+            <a:pPr marL="0" indent="0" algn="l">
               <a:lnSpc>
                 <a:spcPct val="109091"/>
               </a:lnSpc>
@@ -5771,13 +5654,13 @@
             <a:r>
               <a:rPr lang="en-US" sz="1800" dirty="0">
                 <a:solidFill>
-                  <a:srgbClr val="FFFFFF"/>
-                </a:solidFill>
-                <a:latin typeface="Open Sans" pitchFamily="34" charset="0"/>
-                <a:ea typeface="Open Sans" pitchFamily="34" charset="-122"/>
-                <a:cs typeface="Open Sans" pitchFamily="34" charset="-120"/>
-              </a:rPr>
-              <a:t>so the image is tied to a build, not only a tag</a:t>
+                  <a:srgbClr val="40C057"/>
+                </a:solidFill>
+                <a:latin typeface="Open Sans" pitchFamily="34" charset="0"/>
+                <a:ea typeface="Open Sans" pitchFamily="34" charset="-122"/>
+                <a:cs typeface="Open Sans" pitchFamily="34" charset="-120"/>
+              </a:rPr>
+              <a:t>▪</a:t>
             </a:r>
             <a:endParaRPr lang="en-US" sz="1800" dirty="0"/>
           </a:p>
@@ -5785,78 +5668,34 @@
       </p:sp>
       <p:sp>
         <p:nvSpPr>
-          <p:cNvPr id="6" name="Text 4"/>
-          <p:cNvSpPr/>
-          <p:nvPr/>
-        </p:nvSpPr>
-        <p:spPr>
-          <a:xfrm>
-            <a:off x="1143000" y="5672138"/>
-            <a:ext cx="191839" cy="381000"/>
-          </a:xfrm>
-          <a:prstGeom prst="rect">
-            <a:avLst/>
-          </a:prstGeom>
-          <a:noFill/>
-          <a:ln/>
-        </p:spPr>
-        <p:txBody>
-          <a:bodyPr wrap="square" lIns="25400" tIns="25400" rIns="25400" bIns="25400" rtlCol="0" anchor="t">
-            <a:normAutofit/>
-          </a:bodyPr>
-          <a:lstStyle/>
-          <a:p>
-            <a:pPr algn="l" indent="0" marL="0">
+          <p:cNvPr id="9" name="Text 7"/>
+          <p:cNvSpPr/>
+          <p:nvPr/>
+        </p:nvSpPr>
+        <p:spPr>
+          <a:xfrm>
+            <a:off x="1391989" y="6586538"/>
+            <a:ext cx="7670627" cy="723900"/>
+          </a:xfrm>
+          <a:prstGeom prst="rect">
+            <a:avLst/>
+          </a:prstGeom>
+          <a:noFill/>
+          <a:ln/>
+        </p:spPr>
+        <p:txBody>
+          <a:bodyPr wrap="square" lIns="25400" tIns="25400" rIns="25400" bIns="25400" rtlCol="0" anchor="t">
+            <a:normAutofit/>
+          </a:bodyPr>
+          <a:lstStyle/>
+          <a:p>
+            <a:pPr marL="0" indent="0" algn="l">
               <a:lnSpc>
                 <a:spcPct val="109091"/>
               </a:lnSpc>
               <a:buNone/>
             </a:pPr>
             <a:r>
-              <a:rPr lang="en-US" sz="1800" dirty="0">
-                <a:solidFill>
-                  <a:srgbClr val="40C057"/>
-                </a:solidFill>
-                <a:latin typeface="Open Sans" pitchFamily="34" charset="0"/>
-                <a:ea typeface="Open Sans" pitchFamily="34" charset="-122"/>
-                <a:cs typeface="Open Sans" pitchFamily="34" charset="-120"/>
-              </a:rPr>
-              <a:t>▪</a:t>
-            </a:r>
-            <a:endParaRPr lang="en-US" sz="1800" dirty="0"/>
-          </a:p>
-        </p:txBody>
-      </p:sp>
-      <p:sp>
-        <p:nvSpPr>
-          <p:cNvPr id="7" name="Text 5"/>
-          <p:cNvSpPr/>
-          <p:nvPr/>
-        </p:nvSpPr>
-        <p:spPr>
-          <a:xfrm>
-            <a:off x="1391989" y="5672138"/>
-            <a:ext cx="7670627" cy="723900"/>
-          </a:xfrm>
-          <a:prstGeom prst="rect">
-            <a:avLst/>
-          </a:prstGeom>
-          <a:noFill/>
-          <a:ln/>
-        </p:spPr>
-        <p:txBody>
-          <a:bodyPr wrap="square" lIns="25400" tIns="25400" rIns="25400" bIns="25400" rtlCol="0" anchor="t">
-            <a:normAutofit/>
-          </a:bodyPr>
-          <a:lstStyle/>
-          <a:p>
-            <a:pPr algn="l" indent="0" marL="0">
-              <a:lnSpc>
-                <a:spcPct val="109091"/>
-              </a:lnSpc>
-              <a:buNone/>
-            </a:pPr>
-            <a:r>
               <a:rPr lang="en-US" sz="1800" b="1" dirty="0">
                 <a:solidFill>
                   <a:srgbClr val="FFFFFF"/>
@@ -5865,119 +5704,8 @@
                 <a:ea typeface="Open Sans" pitchFamily="34" charset="-122"/>
                 <a:cs typeface="Open Sans" pitchFamily="34" charset="-120"/>
               </a:rPr>
-              <a:t>Evidence </a:t>
-            </a:r>
-            <a:pPr algn="l" indent="0" marL="0">
-              <a:lnSpc>
-                <a:spcPct val="109091"/>
-              </a:lnSpc>
-              <a:buNone/>
-            </a:pPr>
-            <a:r>
-              <a:rPr lang="en-US" sz="1800" dirty="0">
-                <a:solidFill>
-                  <a:srgbClr val="FFFFFF"/>
-                </a:solidFill>
-                <a:latin typeface="Open Sans" pitchFamily="34" charset="0"/>
-                <a:ea typeface="Open Sans" pitchFamily="34" charset="-122"/>
-                <a:cs typeface="Open Sans" pitchFamily="34" charset="-120"/>
-              </a:rPr>
-              <a:t>— signed lineage on the digest: child image, immediate base, preferably root Golden digest</a:t>
-            </a:r>
-            <a:endParaRPr lang="en-US" sz="1800" dirty="0"/>
-          </a:p>
-        </p:txBody>
-      </p:sp>
-      <p:sp>
-        <p:nvSpPr>
-          <p:cNvPr id="8" name="Text 6"/>
-          <p:cNvSpPr/>
-          <p:nvPr/>
-        </p:nvSpPr>
-        <p:spPr>
-          <a:xfrm>
-            <a:off x="1143000" y="6586538"/>
-            <a:ext cx="191839" cy="381000"/>
-          </a:xfrm>
-          <a:prstGeom prst="rect">
-            <a:avLst/>
-          </a:prstGeom>
-          <a:noFill/>
-          <a:ln/>
-        </p:spPr>
-        <p:txBody>
-          <a:bodyPr wrap="square" lIns="25400" tIns="25400" rIns="25400" bIns="25400" rtlCol="0" anchor="t">
-            <a:normAutofit/>
-          </a:bodyPr>
-          <a:lstStyle/>
-          <a:p>
-            <a:pPr algn="l" indent="0" marL="0">
-              <a:lnSpc>
-                <a:spcPct val="109091"/>
-              </a:lnSpc>
-              <a:buNone/>
-            </a:pPr>
-            <a:r>
-              <a:rPr lang="en-US" sz="1800" dirty="0">
-                <a:solidFill>
-                  <a:srgbClr val="40C057"/>
-                </a:solidFill>
-                <a:latin typeface="Open Sans" pitchFamily="34" charset="0"/>
-                <a:ea typeface="Open Sans" pitchFamily="34" charset="-122"/>
-                <a:cs typeface="Open Sans" pitchFamily="34" charset="-120"/>
-              </a:rPr>
-              <a:t>▪</a:t>
-            </a:r>
-            <a:endParaRPr lang="en-US" sz="1800" dirty="0"/>
-          </a:p>
-        </p:txBody>
-      </p:sp>
-      <p:sp>
-        <p:nvSpPr>
-          <p:cNvPr id="9" name="Text 7"/>
-          <p:cNvSpPr/>
-          <p:nvPr/>
-        </p:nvSpPr>
-        <p:spPr>
-          <a:xfrm>
-            <a:off x="1391989" y="6586538"/>
-            <a:ext cx="7670627" cy="723900"/>
-          </a:xfrm>
-          <a:prstGeom prst="rect">
-            <a:avLst/>
-          </a:prstGeom>
-          <a:noFill/>
-          <a:ln/>
-        </p:spPr>
-        <p:txBody>
-          <a:bodyPr wrap="square" lIns="25400" tIns="25400" rIns="25400" bIns="25400" rtlCol="0" anchor="t">
-            <a:normAutofit/>
-          </a:bodyPr>
-          <a:lstStyle/>
-          <a:p>
-            <a:pPr algn="l" indent="0" marL="0">
-              <a:lnSpc>
-                <a:spcPct val="109091"/>
-              </a:lnSpc>
-              <a:buNone/>
-            </a:pPr>
-            <a:r>
-              <a:rPr lang="en-US" sz="1800" b="1" dirty="0">
-                <a:solidFill>
-                  <a:srgbClr val="FFFFFF"/>
-                </a:solidFill>
-                <a:latin typeface="Open Sans" pitchFamily="34" charset="0"/>
-                <a:ea typeface="Open Sans" pitchFamily="34" charset="-122"/>
-                <a:cs typeface="Open Sans" pitchFamily="34" charset="-120"/>
-              </a:rPr>
               <a:t>Query </a:t>
             </a:r>
-            <a:pPr algn="l" indent="0" marL="0">
-              <a:lnSpc>
-                <a:spcPct val="109091"/>
-              </a:lnSpc>
-              <a:buNone/>
-            </a:pPr>
             <a:r>
               <a:rPr lang="en-US" sz="1800" dirty="0">
                 <a:solidFill>
@@ -6019,6 +5747,13 @@
             <a:prstDash val="solid"/>
           </a:ln>
         </p:spPr>
+        <p:txBody>
+          <a:bodyPr/>
+          <a:lstStyle/>
+          <a:p>
+            <a:endParaRPr lang="en-US"/>
+          </a:p>
+        </p:txBody>
       </p:sp>
       <p:sp>
         <p:nvSpPr>
@@ -6039,11 +5774,11 @@
         </p:spPr>
         <p:txBody>
           <a:bodyPr wrap="square" lIns="25400" tIns="25400" rIns="25400" bIns="25400" rtlCol="0" anchor="t">
-            <a:normAutofit/>
-          </a:bodyPr>
-          <a:lstStyle/>
-          <a:p>
-            <a:pPr algn="l" indent="0" marL="0">
+            <a:normAutofit lnSpcReduction="10000"/>
+          </a:bodyPr>
+          <a:lstStyle/>
+          <a:p>
+            <a:pPr marL="0" indent="0" algn="l">
               <a:buNone/>
             </a:pPr>
             <a:r>
@@ -6084,7 +5819,7 @@
           </a:bodyPr>
           <a:lstStyle/>
           <a:p>
-            <a:pPr algn="l" indent="0" marL="0">
+            <a:pPr marL="0" indent="0" algn="l">
               <a:buNone/>
             </a:pPr>
             <a:r>
@@ -6128,6 +5863,13 @@
             <a:prstDash val="solid"/>
           </a:ln>
         </p:spPr>
+        <p:txBody>
+          <a:bodyPr/>
+          <a:lstStyle/>
+          <a:p>
+            <a:endParaRPr lang="en-US"/>
+          </a:p>
+        </p:txBody>
       </p:sp>
       <p:sp>
         <p:nvSpPr>
@@ -6152,7 +5894,7 @@
           </a:bodyPr>
           <a:lstStyle/>
           <a:p>
-            <a:pPr algn="l" indent="0" marL="0">
+            <a:pPr marL="0" indent="0" algn="l">
               <a:buNone/>
             </a:pPr>
             <a:r>
@@ -6193,7 +5935,7 @@
           </a:bodyPr>
           <a:lstStyle/>
           <a:p>
-            <a:pPr algn="l" indent="0" marL="0">
+            <a:pPr marL="0" indent="0" algn="l">
               <a:buNone/>
             </a:pPr>
             <a:r>
@@ -6237,6 +5979,13 @@
             <a:prstDash val="solid"/>
           </a:ln>
         </p:spPr>
+        <p:txBody>
+          <a:bodyPr/>
+          <a:lstStyle/>
+          <a:p>
+            <a:endParaRPr lang="en-US"/>
+          </a:p>
+        </p:txBody>
       </p:sp>
       <p:sp>
         <p:nvSpPr>
@@ -6257,11 +6006,11 @@
         </p:spPr>
         <p:txBody>
           <a:bodyPr wrap="square" lIns="25400" tIns="25400" rIns="25400" bIns="25400" rtlCol="0" anchor="t">
-            <a:normAutofit/>
-          </a:bodyPr>
-          <a:lstStyle/>
-          <a:p>
-            <a:pPr algn="l" indent="0" marL="0">
+            <a:normAutofit lnSpcReduction="10000"/>
+          </a:bodyPr>
+          <a:lstStyle/>
+          <a:p>
+            <a:pPr marL="0" indent="0" algn="l">
               <a:buNone/>
             </a:pPr>
             <a:r>
@@ -6302,7 +6051,7 @@
           </a:bodyPr>
           <a:lstStyle/>
           <a:p>
-            <a:pPr algn="l" indent="0" marL="0">
+            <a:pPr marL="0" indent="0" algn="l">
               <a:buNone/>
             </a:pPr>
             <a:r>
@@ -6336,6 +6085,7 @@
         <a:solidFill>
           <a:srgbClr val="0D1117"/>
         </a:solidFill>
+        <a:effectLst/>
       </p:bgPr>
     </p:bg>
     <p:spTree>
@@ -6375,7 +6125,7 @@
           </a:bodyPr>
           <a:lstStyle/>
           <a:p>
-            <a:pPr algn="l" indent="0" marL="0">
+            <a:pPr marL="0" indent="0" algn="l">
               <a:buNone/>
             </a:pPr>
             <a:r>
@@ -6416,7 +6166,7 @@
           </a:bodyPr>
           <a:lstStyle/>
           <a:p>
-            <a:pPr algn="l" indent="0" marL="0">
+            <a:pPr marL="0" indent="0" algn="l">
               <a:buNone/>
             </a:pPr>
             <a:r>
@@ -6430,9 +6180,6 @@
               </a:rPr>
               <a:t>AppTrust does not replace Evidence or Build Info. It </a:t>
             </a:r>
-            <a:pPr algn="l" indent="0" marL="0">
-              <a:buNone/>
-            </a:pPr>
             <a:r>
               <a:rPr lang="en-US" sz="1800" b="1" dirty="0">
                 <a:solidFill>
@@ -6444,9 +6191,6 @@
               </a:rPr>
               <a:t>governs </a:t>
             </a:r>
-            <a:pPr algn="l" indent="0" marL="0">
-              <a:buNone/>
-            </a:pPr>
             <a:r>
               <a:rPr lang="en-US" sz="1800" dirty="0">
                 <a:solidFill>
@@ -6488,6 +6232,13 @@
             <a:prstDash val="solid"/>
           </a:ln>
         </p:spPr>
+        <p:txBody>
+          <a:bodyPr/>
+          <a:lstStyle/>
+          <a:p>
+            <a:endParaRPr lang="en-US"/>
+          </a:p>
+        </p:txBody>
       </p:sp>
       <p:sp>
         <p:nvSpPr>
@@ -6512,7 +6263,7 @@
           </a:bodyPr>
           <a:lstStyle/>
           <a:p>
-            <a:pPr algn="l" indent="0" marL="0">
+            <a:pPr marL="0" indent="0" algn="l">
               <a:buNone/>
             </a:pPr>
             <a:r>
@@ -6553,7 +6304,7 @@
           </a:bodyPr>
           <a:lstStyle/>
           <a:p>
-            <a:pPr algn="l" indent="0" marL="0">
+            <a:pPr marL="0" indent="0" algn="l">
               <a:lnSpc>
                 <a:spcPct val="112500"/>
               </a:lnSpc>
@@ -6597,7 +6348,7 @@
           </a:bodyPr>
           <a:lstStyle/>
           <a:p>
-            <a:pPr algn="ctr" indent="0" marL="0">
+            <a:pPr marL="0" indent="0" algn="ctr">
               <a:buNone/>
             </a:pPr>
             <a:r>
@@ -6641,6 +6392,13 @@
             <a:prstDash val="solid"/>
           </a:ln>
         </p:spPr>
+        <p:txBody>
+          <a:bodyPr/>
+          <a:lstStyle/>
+          <a:p>
+            <a:endParaRPr lang="en-US"/>
+          </a:p>
+        </p:txBody>
       </p:sp>
       <p:sp>
         <p:nvSpPr>
@@ -6665,7 +6423,7 @@
           </a:bodyPr>
           <a:lstStyle/>
           <a:p>
-            <a:pPr algn="l" indent="0" marL="0">
+            <a:pPr marL="0" indent="0" algn="l">
               <a:buNone/>
             </a:pPr>
             <a:r>
@@ -6706,7 +6464,7 @@
           </a:bodyPr>
           <a:lstStyle/>
           <a:p>
-            <a:pPr algn="l" indent="0" marL="0">
+            <a:pPr marL="0" indent="0" algn="l">
               <a:lnSpc>
                 <a:spcPct val="112500"/>
               </a:lnSpc>
@@ -6750,7 +6508,7 @@
           </a:bodyPr>
           <a:lstStyle/>
           <a:p>
-            <a:pPr algn="ctr" indent="0" marL="0">
+            <a:pPr marL="0" indent="0" algn="ctr">
               <a:buNone/>
             </a:pPr>
             <a:r>
@@ -6794,6 +6552,13 @@
             <a:prstDash val="solid"/>
           </a:ln>
         </p:spPr>
+        <p:txBody>
+          <a:bodyPr/>
+          <a:lstStyle/>
+          <a:p>
+            <a:endParaRPr lang="en-US"/>
+          </a:p>
+        </p:txBody>
       </p:sp>
       <p:sp>
         <p:nvSpPr>
@@ -6818,7 +6583,7 @@
           </a:bodyPr>
           <a:lstStyle/>
           <a:p>
-            <a:pPr algn="l" indent="0" marL="0">
+            <a:pPr marL="0" indent="0" algn="l">
               <a:buNone/>
             </a:pPr>
             <a:r>
@@ -6859,7 +6624,7 @@
           </a:bodyPr>
           <a:lstStyle/>
           <a:p>
-            <a:pPr algn="l" indent="0" marL="0">
+            <a:pPr marL="0" indent="0" algn="l">
               <a:lnSpc>
                 <a:spcPct val="112500"/>
               </a:lnSpc>
@@ -6903,7 +6668,7 @@
           </a:bodyPr>
           <a:lstStyle/>
           <a:p>
-            <a:pPr algn="l" indent="0" marL="0">
+            <a:pPr marL="0" indent="0" algn="l">
               <a:lnSpc>
                 <a:spcPct val="112500"/>
               </a:lnSpc>
@@ -6947,7 +6712,7 @@
           </a:bodyPr>
           <a:lstStyle/>
           <a:p>
-            <a:pPr algn="l" indent="0" marL="0">
+            <a:pPr marL="0" indent="0" algn="l">
               <a:buNone/>
             </a:pPr>
             <a:r>
@@ -6981,6 +6746,7 @@
         <a:solidFill>
           <a:srgbClr val="0D1117"/>
         </a:solidFill>
+        <a:effectLst/>
       </p:bgPr>
     </p:bg>
     <p:spTree>
@@ -7020,7 +6786,7 @@
           </a:bodyPr>
           <a:lstStyle/>
           <a:p>
-            <a:pPr algn="l" indent="0" marL="0">
+            <a:pPr marL="0" indent="0" algn="l">
               <a:buNone/>
             </a:pPr>
             <a:r>
@@ -7061,23 +6827,12 @@
           </a:bodyPr>
           <a:lstStyle/>
           <a:p>
-            <a:pPr algn="l" indent="0" marL="0">
+            <a:pPr marL="0" indent="0" algn="l">
               <a:lnSpc>
                 <a:spcPct val="109091"/>
               </a:lnSpc>
               <a:buNone/>
             </a:pPr>
-            <a:r>
-              <a:rPr lang="en-US" sz="1800" dirty="0">
-                <a:solidFill>
-                  <a:srgbClr val="40C057"/>
-                </a:solidFill>
-                <a:latin typeface="Open Sans" pitchFamily="34" charset="0"/>
-                <a:ea typeface="Open Sans" pitchFamily="34" charset="-122"/>
-                <a:cs typeface="Open Sans" pitchFamily="34" charset="-120"/>
-              </a:rPr>
-              <a:t>▪</a:t>
-            </a:r>
             <a:endParaRPr lang="en-US" sz="1800" dirty="0"/>
           </a:p>
         </p:txBody>
@@ -7090,7 +6845,7 @@
         </p:nvSpPr>
         <p:spPr>
           <a:xfrm>
-            <a:off x="1391989" y="4857750"/>
+            <a:off x="1108560" y="4168203"/>
             <a:ext cx="5253648" cy="381000"/>
           </a:xfrm>
           <a:prstGeom prst="rect">
@@ -7105,7 +6860,7 @@
           </a:bodyPr>
           <a:lstStyle/>
           <a:p>
-            <a:pPr algn="l" indent="0" marL="0">
+            <a:pPr marL="0" indent="0" algn="l">
               <a:lnSpc>
                 <a:spcPct val="109091"/>
               </a:lnSpc>
@@ -7149,23 +6904,12 @@
           </a:bodyPr>
           <a:lstStyle/>
           <a:p>
-            <a:pPr algn="l" indent="0" marL="0">
+            <a:pPr marL="0" indent="0" algn="l">
               <a:lnSpc>
                 <a:spcPct val="109091"/>
               </a:lnSpc>
               <a:buNone/>
             </a:pPr>
-            <a:r>
-              <a:rPr lang="en-US" sz="1800" dirty="0">
-                <a:solidFill>
-                  <a:srgbClr val="40C057"/>
-                </a:solidFill>
-                <a:latin typeface="Open Sans" pitchFamily="34" charset="0"/>
-                <a:ea typeface="Open Sans" pitchFamily="34" charset="-122"/>
-                <a:cs typeface="Open Sans" pitchFamily="34" charset="-120"/>
-              </a:rPr>
-              <a:t>▪</a:t>
-            </a:r>
             <a:endParaRPr lang="en-US" sz="1800" dirty="0"/>
           </a:p>
         </p:txBody>
@@ -7178,7 +6922,7 @@
         </p:nvSpPr>
         <p:spPr>
           <a:xfrm>
-            <a:off x="1391989" y="5429250"/>
+            <a:off x="1108560" y="4739703"/>
             <a:ext cx="5763356" cy="723900"/>
           </a:xfrm>
           <a:prstGeom prst="rect">
@@ -7193,7 +6937,7 @@
           </a:bodyPr>
           <a:lstStyle/>
           <a:p>
-            <a:pPr algn="l" indent="0" marL="0">
+            <a:pPr marL="0" indent="0" algn="l">
               <a:lnSpc>
                 <a:spcPct val="109091"/>
               </a:lnSpc>
@@ -7216,28 +6960,28 @@
       </p:sp>
       <p:sp>
         <p:nvSpPr>
-          <p:cNvPr id="7" name="Text 5"/>
-          <p:cNvSpPr/>
-          <p:nvPr/>
-        </p:nvSpPr>
-        <p:spPr>
-          <a:xfrm>
-            <a:off x="1143000" y="6343650"/>
-            <a:ext cx="191839" cy="381000"/>
-          </a:xfrm>
-          <a:prstGeom prst="rect">
-            <a:avLst/>
-          </a:prstGeom>
-          <a:noFill/>
-          <a:ln/>
-        </p:spPr>
-        <p:txBody>
-          <a:bodyPr wrap="square" lIns="25400" tIns="25400" rIns="25400" bIns="25400" rtlCol="0" anchor="t">
-            <a:normAutofit/>
-          </a:bodyPr>
-          <a:lstStyle/>
-          <a:p>
-            <a:pPr algn="l" indent="0" marL="0">
+          <p:cNvPr id="8" name="Text 6"/>
+          <p:cNvSpPr/>
+          <p:nvPr/>
+        </p:nvSpPr>
+        <p:spPr>
+          <a:xfrm>
+            <a:off x="1108560" y="5654103"/>
+            <a:ext cx="3504560" cy="381000"/>
+          </a:xfrm>
+          <a:prstGeom prst="rect">
+            <a:avLst/>
+          </a:prstGeom>
+          <a:noFill/>
+          <a:ln/>
+        </p:spPr>
+        <p:txBody>
+          <a:bodyPr wrap="square" lIns="25400" tIns="25400" rIns="25400" bIns="25400" rtlCol="0" anchor="t">
+            <a:normAutofit/>
+          </a:bodyPr>
+          <a:lstStyle/>
+          <a:p>
+            <a:pPr marL="0" indent="0" algn="l">
               <a:lnSpc>
                 <a:spcPct val="109091"/>
               </a:lnSpc>
@@ -7246,88 +6990,17 @@
             <a:r>
               <a:rPr lang="en-US" sz="1800" dirty="0">
                 <a:solidFill>
-                  <a:srgbClr val="40C057"/>
-                </a:solidFill>
-                <a:latin typeface="Open Sans" pitchFamily="34" charset="0"/>
-                <a:ea typeface="Open Sans" pitchFamily="34" charset="-122"/>
-                <a:cs typeface="Open Sans" pitchFamily="34" charset="-120"/>
-              </a:rPr>
-              <a:t>▪</a:t>
+                  <a:srgbClr val="FFFFFF"/>
+                </a:solidFill>
+                <a:latin typeface="Open Sans" pitchFamily="34" charset="0"/>
+                <a:ea typeface="Open Sans" pitchFamily="34" charset="-122"/>
+                <a:cs typeface="Open Sans" pitchFamily="34" charset="-120"/>
+              </a:rPr>
+              <a:t>No second provenance model</a:t>
             </a:r>
             <a:endParaRPr lang="en-US" sz="1800" dirty="0"/>
           </a:p>
         </p:txBody>
-      </p:sp>
-      <p:sp>
-        <p:nvSpPr>
-          <p:cNvPr id="8" name="Text 6"/>
-          <p:cNvSpPr/>
-          <p:nvPr/>
-        </p:nvSpPr>
-        <p:spPr>
-          <a:xfrm>
-            <a:off x="1391989" y="6343650"/>
-            <a:ext cx="3504560" cy="381000"/>
-          </a:xfrm>
-          <a:prstGeom prst="rect">
-            <a:avLst/>
-          </a:prstGeom>
-          <a:noFill/>
-          <a:ln/>
-        </p:spPr>
-        <p:txBody>
-          <a:bodyPr wrap="square" lIns="25400" tIns="25400" rIns="25400" bIns="25400" rtlCol="0" anchor="t">
-            <a:normAutofit/>
-          </a:bodyPr>
-          <a:lstStyle/>
-          <a:p>
-            <a:pPr algn="l" indent="0" marL="0">
-              <a:lnSpc>
-                <a:spcPct val="109091"/>
-              </a:lnSpc>
-              <a:buNone/>
-            </a:pPr>
-            <a:r>
-              <a:rPr lang="en-US" sz="1800" dirty="0">
-                <a:solidFill>
-                  <a:srgbClr val="FFFFFF"/>
-                </a:solidFill>
-                <a:latin typeface="Open Sans" pitchFamily="34" charset="0"/>
-                <a:ea typeface="Open Sans" pitchFamily="34" charset="-122"/>
-                <a:cs typeface="Open Sans" pitchFamily="34" charset="-120"/>
-              </a:rPr>
-              <a:t>No second provenance model</a:t>
-            </a:r>
-            <a:endParaRPr lang="en-US" sz="1800" dirty="0"/>
-          </a:p>
-        </p:txBody>
-      </p:sp>
-      <p:sp>
-        <p:nvSpPr>
-          <p:cNvPr id="9" name="Shape 7"/>
-          <p:cNvSpPr/>
-          <p:nvPr/>
-        </p:nvSpPr>
-        <p:spPr>
-          <a:xfrm>
-            <a:off x="7597080" y="2209800"/>
-            <a:ext cx="9547920" cy="7124700"/>
-          </a:xfrm>
-          <a:prstGeom prst="roundRect">
-            <a:avLst>
-              <a:gd name="adj" fmla="val 1070"/>
-            </a:avLst>
-          </a:prstGeom>
-          <a:solidFill>
-            <a:srgbClr val="1A2332"/>
-          </a:solidFill>
-          <a:ln w="9525">
-            <a:solidFill>
-              <a:srgbClr val="2D3748"/>
-            </a:solidFill>
-            <a:prstDash val="solid"/>
-          </a:ln>
-        </p:spPr>
       </p:sp>
       <p:sp>
         <p:nvSpPr>
@@ -7352,7 +7025,7 @@
           </a:bodyPr>
           <a:lstStyle/>
           <a:p>
-            <a:pPr algn="l" indent="0" marL="0">
+            <a:pPr marL="0" indent="0" algn="l">
               <a:buNone/>
             </a:pPr>
             <a:r>
@@ -7393,7 +7066,7 @@
           </a:bodyPr>
           <a:lstStyle/>
           <a:p>
-            <a:pPr algn="ctr" indent="0" marL="0">
+            <a:pPr marL="0" indent="0" algn="ctr">
               <a:buNone/>
             </a:pPr>
             <a:r>
@@ -7411,6 +7084,36 @@
           </a:p>
         </p:txBody>
       </p:sp>
+      <p:pic>
+        <p:nvPicPr>
+          <p:cNvPr id="12" name="Picture 11">
+            <a:extLst>
+              <a:ext uri="{FF2B5EF4-FFF2-40B4-BE49-F238E27FC236}">
+                <a16:creationId xmlns:a16="http://schemas.microsoft.com/office/drawing/2014/main" id="{AFD0D302-8ADE-3355-412A-E71899991152}"/>
+              </a:ext>
+            </a:extLst>
+          </p:cNvPr>
+          <p:cNvPicPr>
+            <a:picLocks noChangeAspect="1"/>
+          </p:cNvPicPr>
+          <p:nvPr/>
+        </p:nvPicPr>
+        <p:blipFill>
+          <a:blip r:embed="rId3"/>
+          <a:stretch>
+            <a:fillRect/>
+          </a:stretch>
+        </p:blipFill>
+        <p:spPr>
+          <a:xfrm>
+            <a:off x="6645637" y="3146295"/>
+            <a:ext cx="10808717" cy="4842135"/>
+          </a:xfrm>
+          <a:prstGeom prst="rect">
+            <a:avLst/>
+          </a:prstGeom>
+        </p:spPr>
+      </p:pic>
     </p:spTree>
   </p:cSld>
   <p:clrMapOvr>
@@ -7712,4 +7415,319 @@
     </a:ext>
   </a:extLst>
 </a:theme>
+</file>
+
+<file path=ppt/theme/theme2.xml><?xml version="1.0" encoding="utf-8"?>
+<a:theme xmlns:a="http://schemas.openxmlformats.org/drawingml/2006/main" name="Office Theme">
+  <a:themeElements>
+    <a:clrScheme name="Office">
+      <a:dk1>
+        <a:sysClr val="windowText" lastClr="000000"/>
+      </a:dk1>
+      <a:lt1>
+        <a:sysClr val="window" lastClr="FFFFFF"/>
+      </a:lt1>
+      <a:dk2>
+        <a:srgbClr val="0E2841"/>
+      </a:dk2>
+      <a:lt2>
+        <a:srgbClr val="E8E8E8"/>
+      </a:lt2>
+      <a:accent1>
+        <a:srgbClr val="156082"/>
+      </a:accent1>
+      <a:accent2>
+        <a:srgbClr val="E97132"/>
+      </a:accent2>
+      <a:accent3>
+        <a:srgbClr val="196B24"/>
+      </a:accent3>
+      <a:accent4>
+        <a:srgbClr val="0F9ED5"/>
+      </a:accent4>
+      <a:accent5>
+        <a:srgbClr val="A02B93"/>
+      </a:accent5>
+      <a:accent6>
+        <a:srgbClr val="4EA72E"/>
+      </a:accent6>
+      <a:hlink>
+        <a:srgbClr val="467886"/>
+      </a:hlink>
+      <a:folHlink>
+        <a:srgbClr val="96607D"/>
+      </a:folHlink>
+    </a:clrScheme>
+    <a:fontScheme name="Office">
+      <a:majorFont>
+        <a:latin typeface="Aptos Display" panose="02110004020202020204"/>
+        <a:ea typeface=""/>
+        <a:cs typeface=""/>
+        <a:font script="Jpan" typeface="游ゴシック Light"/>
+        <a:font script="Hang" typeface="맑은 고딕"/>
+        <a:font script="Hans" typeface="等线 Light"/>
+        <a:font script="Hant" typeface="新細明體"/>
+        <a:font script="Arab" typeface="Times New Roman"/>
+        <a:font script="Hebr" typeface="Times New Roman"/>
+        <a:font script="Thai" typeface="Angsana New"/>
+        <a:font script="Ethi" typeface="Nyala"/>
+        <a:font script="Beng" typeface="Vrinda"/>
+        <a:font script="Gujr" typeface="Shruti"/>
+        <a:font script="Khmr" typeface="MoolBoran"/>
+        <a:font script="Knda" typeface="Tunga"/>
+        <a:font script="Guru" typeface="Raavi"/>
+        <a:font script="Cans" typeface="Euphemia"/>
+        <a:font script="Cher" typeface="Plantagenet Cherokee"/>
+        <a:font script="Yiii" typeface="Microsoft Yi Baiti"/>
+        <a:font script="Tibt" typeface="Microsoft Himalaya"/>
+        <a:font script="Thaa" typeface="MV Boli"/>
+        <a:font script="Deva" typeface="Mangal"/>
+        <a:font script="Telu" typeface="Gautami"/>
+        <a:font script="Taml" typeface="Latha"/>
+        <a:font script="Syrc" typeface="Estrangelo Edessa"/>
+        <a:font script="Orya" typeface="Kalinga"/>
+        <a:font script="Mlym" typeface="Kartika"/>
+        <a:font script="Laoo" typeface="DokChampa"/>
+        <a:font script="Sinh" typeface="Iskoola Pota"/>
+        <a:font script="Mong" typeface="Mongolian Baiti"/>
+        <a:font script="Viet" typeface="Times New Roman"/>
+        <a:font script="Uigh" typeface="Microsoft Uighur"/>
+        <a:font script="Geor" typeface="Sylfaen"/>
+        <a:font script="Armn" typeface="Arial"/>
+        <a:font script="Bugi" typeface="Leelawadee UI"/>
+        <a:font script="Bopo" typeface="Microsoft JhengHei"/>
+        <a:font script="Java" typeface="Javanese Text"/>
+        <a:font script="Lisu" typeface="Segoe UI"/>
+        <a:font script="Mymr" typeface="Myanmar Text"/>
+        <a:font script="Nkoo" typeface="Ebrima"/>
+        <a:font script="Olck" typeface="Nirmala UI"/>
+        <a:font script="Osma" typeface="Ebrima"/>
+        <a:font script="Phag" typeface="Phagspa"/>
+        <a:font script="Syrn" typeface="Estrangelo Edessa"/>
+        <a:font script="Syrj" typeface="Estrangelo Edessa"/>
+        <a:font script="Syre" typeface="Estrangelo Edessa"/>
+        <a:font script="Sora" typeface="Nirmala UI"/>
+        <a:font script="Tale" typeface="Microsoft Tai Le"/>
+        <a:font script="Talu" typeface="Microsoft New Tai Lue"/>
+        <a:font script="Tfng" typeface="Ebrima"/>
+      </a:majorFont>
+      <a:minorFont>
+        <a:latin typeface="Aptos" panose="02110004020202020204"/>
+        <a:ea typeface=""/>
+        <a:cs typeface=""/>
+        <a:font script="Jpan" typeface="游ゴシック"/>
+        <a:font script="Hang" typeface="맑은 고딕"/>
+        <a:font script="Hans" typeface="等线"/>
+        <a:font script="Hant" typeface="新細明體"/>
+        <a:font script="Arab" typeface="Arial"/>
+        <a:font script="Hebr" typeface="Arial"/>
+        <a:font script="Thai" typeface="Cordia New"/>
+        <a:font script="Ethi" typeface="Nyala"/>
+        <a:font script="Beng" typeface="Vrinda"/>
+        <a:font script="Gujr" typeface="Shruti"/>
+        <a:font script="Khmr" typeface="DaunPenh"/>
+        <a:font script="Knda" typeface="Tunga"/>
+        <a:font script="Guru" typeface="Raavi"/>
+        <a:font script="Cans" typeface="Euphemia"/>
+        <a:font script="Cher" typeface="Plantagenet Cherokee"/>
+        <a:font script="Yiii" typeface="Microsoft Yi Baiti"/>
+        <a:font script="Tibt" typeface="Microsoft Himalaya"/>
+        <a:font script="Thaa" typeface="MV Boli"/>
+        <a:font script="Deva" typeface="Mangal"/>
+        <a:font script="Telu" typeface="Gautami"/>
+        <a:font script="Taml" typeface="Latha"/>
+        <a:font script="Syrc" typeface="Estrangelo Edessa"/>
+        <a:font script="Orya" typeface="Kalinga"/>
+        <a:font script="Mlym" typeface="Kartika"/>
+        <a:font script="Laoo" typeface="DokChampa"/>
+        <a:font script="Sinh" typeface="Iskoola Pota"/>
+        <a:font script="Mong" typeface="Mongolian Baiti"/>
+        <a:font script="Viet" typeface="Arial"/>
+        <a:font script="Uigh" typeface="Microsoft Uighur"/>
+        <a:font script="Geor" typeface="Sylfaen"/>
+        <a:font script="Armn" typeface="Arial"/>
+        <a:font script="Bugi" typeface="Leelawadee UI"/>
+        <a:font script="Bopo" typeface="Microsoft JhengHei"/>
+        <a:font script="Java" typeface="Javanese Text"/>
+        <a:font script="Lisu" typeface="Segoe UI"/>
+        <a:font script="Mymr" typeface="Myanmar Text"/>
+        <a:font script="Nkoo" typeface="Ebrima"/>
+        <a:font script="Olck" typeface="Nirmala UI"/>
+        <a:font script="Osma" typeface="Ebrima"/>
+        <a:font script="Phag" typeface="Phagspa"/>
+        <a:font script="Syrn" typeface="Estrangelo Edessa"/>
+        <a:font script="Syrj" typeface="Estrangelo Edessa"/>
+        <a:font script="Syre" typeface="Estrangelo Edessa"/>
+        <a:font script="Sora" typeface="Nirmala UI"/>
+        <a:font script="Tale" typeface="Microsoft Tai Le"/>
+        <a:font script="Talu" typeface="Microsoft New Tai Lue"/>
+        <a:font script="Tfng" typeface="Ebrima"/>
+      </a:minorFont>
+    </a:fontScheme>
+    <a:fmtScheme name="Office">
+      <a:fillStyleLst>
+        <a:solidFill>
+          <a:schemeClr val="phClr"/>
+        </a:solidFill>
+        <a:gradFill rotWithShape="1">
+          <a:gsLst>
+            <a:gs pos="0">
+              <a:schemeClr val="phClr">
+                <a:lumMod val="110000"/>
+                <a:satMod val="105000"/>
+                <a:tint val="67000"/>
+              </a:schemeClr>
+            </a:gs>
+            <a:gs pos="50000">
+              <a:schemeClr val="phClr">
+                <a:lumMod val="105000"/>
+                <a:satMod val="103000"/>
+                <a:tint val="73000"/>
+              </a:schemeClr>
+            </a:gs>
+            <a:gs pos="100000">
+              <a:schemeClr val="phClr">
+                <a:lumMod val="105000"/>
+                <a:satMod val="109000"/>
+                <a:tint val="81000"/>
+              </a:schemeClr>
+            </a:gs>
+          </a:gsLst>
+          <a:lin ang="5400000" scaled="0"/>
+        </a:gradFill>
+        <a:gradFill rotWithShape="1">
+          <a:gsLst>
+            <a:gs pos="0">
+              <a:schemeClr val="phClr">
+                <a:satMod val="103000"/>
+                <a:lumMod val="102000"/>
+                <a:tint val="94000"/>
+              </a:schemeClr>
+            </a:gs>
+            <a:gs pos="50000">
+              <a:schemeClr val="phClr">
+                <a:satMod val="110000"/>
+                <a:lumMod val="100000"/>
+                <a:shade val="100000"/>
+              </a:schemeClr>
+            </a:gs>
+            <a:gs pos="100000">
+              <a:schemeClr val="phClr">
+                <a:lumMod val="99000"/>
+                <a:satMod val="120000"/>
+                <a:shade val="78000"/>
+              </a:schemeClr>
+            </a:gs>
+          </a:gsLst>
+          <a:lin ang="5400000" scaled="0"/>
+        </a:gradFill>
+      </a:fillStyleLst>
+      <a:lnStyleLst>
+        <a:ln w="12700" cap="flat" cmpd="sng" algn="ctr">
+          <a:solidFill>
+            <a:schemeClr val="phClr"/>
+          </a:solidFill>
+          <a:prstDash val="solid"/>
+          <a:miter lim="800000"/>
+        </a:ln>
+        <a:ln w="19050" cap="flat" cmpd="sng" algn="ctr">
+          <a:solidFill>
+            <a:schemeClr val="phClr"/>
+          </a:solidFill>
+          <a:prstDash val="solid"/>
+          <a:miter lim="800000"/>
+        </a:ln>
+        <a:ln w="25400" cap="flat" cmpd="sng" algn="ctr">
+          <a:solidFill>
+            <a:schemeClr val="phClr"/>
+          </a:solidFill>
+          <a:prstDash val="solid"/>
+          <a:miter lim="800000"/>
+        </a:ln>
+      </a:lnStyleLst>
+      <a:effectStyleLst>
+        <a:effectStyle>
+          <a:effectLst/>
+        </a:effectStyle>
+        <a:effectStyle>
+          <a:effectLst/>
+        </a:effectStyle>
+        <a:effectStyle>
+          <a:effectLst>
+            <a:outerShdw blurRad="57150" dist="19050" dir="5400000" algn="ctr" rotWithShape="0">
+              <a:srgbClr val="000000">
+                <a:alpha val="63000"/>
+              </a:srgbClr>
+            </a:outerShdw>
+          </a:effectLst>
+        </a:effectStyle>
+      </a:effectStyleLst>
+      <a:bgFillStyleLst>
+        <a:solidFill>
+          <a:schemeClr val="phClr"/>
+        </a:solidFill>
+        <a:solidFill>
+          <a:schemeClr val="phClr">
+            <a:tint val="95000"/>
+            <a:satMod val="170000"/>
+          </a:schemeClr>
+        </a:solidFill>
+        <a:gradFill rotWithShape="1">
+          <a:gsLst>
+            <a:gs pos="0">
+              <a:schemeClr val="phClr">
+                <a:tint val="93000"/>
+                <a:satMod val="150000"/>
+                <a:shade val="98000"/>
+                <a:lumMod val="102000"/>
+              </a:schemeClr>
+            </a:gs>
+            <a:gs pos="50000">
+              <a:schemeClr val="phClr">
+                <a:tint val="98000"/>
+                <a:satMod val="130000"/>
+                <a:shade val="90000"/>
+                <a:lumMod val="103000"/>
+              </a:schemeClr>
+            </a:gs>
+            <a:gs pos="100000">
+              <a:schemeClr val="phClr">
+                <a:shade val="63000"/>
+                <a:satMod val="120000"/>
+              </a:schemeClr>
+            </a:gs>
+          </a:gsLst>
+          <a:lin ang="5400000" scaled="0"/>
+        </a:gradFill>
+      </a:bgFillStyleLst>
+    </a:fmtScheme>
+  </a:themeElements>
+  <a:objectDefaults>
+    <a:lnDef>
+      <a:spPr/>
+      <a:bodyPr/>
+      <a:lstStyle/>
+      <a:style>
+        <a:lnRef idx="2">
+          <a:schemeClr val="accent1"/>
+        </a:lnRef>
+        <a:fillRef idx="0">
+          <a:schemeClr val="accent1"/>
+        </a:fillRef>
+        <a:effectRef idx="1">
+          <a:schemeClr val="accent1"/>
+        </a:effectRef>
+        <a:fontRef idx="minor">
+          <a:schemeClr val="tx1"/>
+        </a:fontRef>
+      </a:style>
+    </a:lnDef>
+  </a:objectDefaults>
+  <a:extraClrSchemeLst/>
+  <a:extLst>
+    <a:ext uri="{05A4C25C-085E-4340-85A3-A5531E510DB2}">
+      <thm15:themeFamily xmlns:thm15="http://schemas.microsoft.com/office/thememl/2012/main" name="Office Theme" id="{2E142A2C-CD16-42D6-873A-C26D2A0506FA}" vid="{1BDDFF52-6CD6-40A5-AB3C-68EB2F1E4D0A}"/>
+    </a:ext>
+  </a:extLst>
+</a:theme>
 </file>
</xml_diff>